<commit_message>
Refactor documentation title for clarity and add VSCode settings for Jupyter integration. Remove temporary PowerPoint file and update existing presentation file.
</commit_message>
<xml_diff>
--- a/workspace_pptx/deep-agents-presentation.pptx
+++ b/workspace_pptx/deep-agents-presentation.pptx
@@ -4,6 +4,9 @@
   <p:sldMasterIdLst>
     <p:sldMasterId id="2147483648" r:id="rId1"/>
   </p:sldMasterIdLst>
+  <p:notesMasterIdLst>
+    <p:notesMasterId r:id="rId9"/>
+  </p:notesMasterIdLst>
   <p:sldIdLst>
     <p:sldId id="256" r:id="rId2"/>
     <p:sldId id="257" r:id="rId3"/>
@@ -13,10 +16,7 @@
     <p:sldId id="261" r:id="rId7"/>
     <p:sldId id="262" r:id="rId8"/>
   </p:sldIdLst>
-  <p:notesMasterIdLst>
-    <p:notesMasterId r:id="rId9"/>
-  </p:notesMasterIdLst>
-  <p:sldSz cx="9144000" cy="5143500"/>
+  <p:sldSz cx="9144000" cy="5143500" type="screen16x9"/>
   <p:notesSz cx="5143500" cy="9144000"/>
   <p:defaultTextStyle>
     <a:lvl1pPr marL="0" algn="l" defTabSz="914400" rtl="0" eaLnBrk="1" latinLnBrk="0" hangingPunct="1">
@@ -110,6 +110,11 @@
       </a:defRPr>
     </a:lvl9pPr>
   </p:defaultTextStyle>
+  <p:extLst>
+    <p:ext uri="{EFAFB233-063F-42B5-8137-9DF3F51BA10A}">
+      <p15:sldGuideLst xmlns:p15="http://schemas.microsoft.com/office/powerpoint/2012/main"/>
+    </p:ext>
+  </p:extLst>
 </p:presentation>
 </file>
 
@@ -135,234 +140,10 @@
           <a:chExt cx="0" cy="0"/>
         </a:xfrm>
       </p:grpSpPr>
-      <p:sp>
-        <p:nvSpPr>
-          <p:cNvPr id="2" name="Header Placeholder 1"/>
-          <p:cNvSpPr>
-            <a:spLocks noGrp="1"/>
-          </p:cNvSpPr>
-          <p:nvPr>
-            <p:ph type="hdr" sz="quarter"/>
-          </p:nvPr>
-        </p:nvSpPr>
-        <p:spPr>
-          <a:xfrm>
-            <a:off x="0" y="0"/>
-            <a:ext cx="2971800" cy="458788"/>
-          </a:xfrm>
-          <a:prstGeom prst="rect">
-            <a:avLst/>
-          </a:prstGeom>
-        </p:spPr>
-        <p:txBody>
-          <a:bodyPr vert="horz" lIns="91440" tIns="45720" rIns="91440" bIns="45720" rtlCol="0"/>
-          <a:lstStyle>
-            <a:lvl1pPr algn="l">
-              <a:defRPr sz="1200"/>
-            </a:lvl1pPr>
-          </a:lstStyle>
-          <a:p>
-            <a:endParaRPr lang="en-US"/>
-          </a:p>
-        </p:txBody>
-      </p:sp>
-      <p:sp>
-        <p:nvSpPr>
-          <p:cNvPr id="3" name="Date Placeholder 2"/>
-          <p:cNvSpPr>
-            <a:spLocks noGrp="1"/>
-          </p:cNvSpPr>
-          <p:nvPr>
-            <p:ph type="dt" idx="1"/>
-          </p:nvPr>
-        </p:nvSpPr>
-        <p:spPr>
-          <a:xfrm>
-            <a:off x="3884613" y="0"/>
-            <a:ext cx="2971800" cy="458788"/>
-          </a:xfrm>
-          <a:prstGeom prst="rect">
-            <a:avLst/>
-          </a:prstGeom>
-        </p:spPr>
-        <p:txBody>
-          <a:bodyPr vert="horz" lIns="91440" tIns="45720" rIns="91440" bIns="45720" rtlCol="0"/>
-          <a:lstStyle>
-            <a:lvl1pPr algn="r">
-              <a:defRPr sz="1200"/>
-            </a:lvl1pPr>
-          </a:lstStyle>
-          <a:p>
-            <a:fld id="{5282F153-3F37-0F45-9E97-73ACFA13230C}" type="datetimeFigureOut">
-              <a:rPr lang="en-US"/>
-              <a:t>7/23/19</a:t>
-            </a:fld>
-            <a:endParaRPr lang="en-US"/>
-          </a:p>
-        </p:txBody>
-      </p:sp>
-      <p:sp>
-        <p:nvSpPr>
-          <p:cNvPr id="4" name="Slide Image Placeholder 3"/>
-          <p:cNvSpPr>
-            <a:spLocks noGrp="1" noRot="1" noChangeAspect="1"/>
-          </p:cNvSpPr>
-          <p:nvPr>
-            <p:ph type="sldImg" idx="2"/>
-          </p:nvPr>
-        </p:nvSpPr>
-        <p:spPr>
-          <a:xfrm>
-            <a:off x="685800" y="1143000"/>
-            <a:ext cx="5486400" cy="3086100"/>
-          </a:xfrm>
-          <a:prstGeom prst="rect">
-            <a:avLst/>
-          </a:prstGeom>
-          <a:noFill/>
-          <a:ln w="12700">
-            <a:solidFill>
-              <a:prstClr val="black"/>
-            </a:solidFill>
-          </a:ln>
-        </p:spPr>
-        <p:txBody>
-          <a:bodyPr vert="horz" lIns="91440" tIns="45720" rIns="91440" bIns="45720" rtlCol="0" anchor="ctr"/>
-          <a:lstStyle/>
-          <a:p>
-            <a:endParaRPr lang="en-US"/>
-          </a:p>
-        </p:txBody>
-      </p:sp>
-      <p:sp>
-        <p:nvSpPr>
-          <p:cNvPr id="5" name="Notes Placeholder 4"/>
-          <p:cNvSpPr>
-            <a:spLocks noGrp="1"/>
-          </p:cNvSpPr>
-          <p:nvPr>
-            <p:ph type="body" sz="quarter" idx="3"/>
-          </p:nvPr>
-        </p:nvSpPr>
-        <p:spPr>
-          <a:xfrm>
-            <a:off x="685800" y="4400550"/>
-            <a:ext cx="5486400" cy="3600450"/>
-          </a:xfrm>
-          <a:prstGeom prst="rect">
-            <a:avLst/>
-          </a:prstGeom>
-        </p:spPr>
-        <p:txBody>
-          <a:bodyPr vert="horz" lIns="91440" tIns="45720" rIns="91440" bIns="45720" rtlCol="0"/>
-          <a:lstStyle/>
-          <a:p>
-            <a:pPr lvl="0"/>
-            <a:r>
-              <a:rPr lang="en-US"/>
-              <a:t>Click to edit Master text styles</a:t>
-            </a:r>
-          </a:p>
-          <a:p>
-            <a:pPr lvl="1"/>
-            <a:r>
-              <a:rPr lang="en-US"/>
-              <a:t>Second level</a:t>
-            </a:r>
-          </a:p>
-          <a:p>
-            <a:pPr lvl="2"/>
-            <a:r>
-              <a:rPr lang="en-US"/>
-              <a:t>Third level</a:t>
-            </a:r>
-          </a:p>
-          <a:p>
-            <a:pPr lvl="3"/>
-            <a:r>
-              <a:rPr lang="en-US"/>
-              <a:t>Fourth level</a:t>
-            </a:r>
-          </a:p>
-          <a:p>
-            <a:pPr lvl="4"/>
-            <a:r>
-              <a:rPr lang="en-US"/>
-              <a:t>Fifth level</a:t>
-            </a:r>
-          </a:p>
-        </p:txBody>
-      </p:sp>
-      <p:sp>
-        <p:nvSpPr>
-          <p:cNvPr id="6" name="Footer Placeholder 5"/>
-          <p:cNvSpPr>
-            <a:spLocks noGrp="1"/>
-          </p:cNvSpPr>
-          <p:nvPr>
-            <p:ph type="ftr" sz="quarter" idx="4"/>
-          </p:nvPr>
-        </p:nvSpPr>
-        <p:spPr>
-          <a:xfrm>
-            <a:off x="0" y="8685213"/>
-            <a:ext cx="2971800" cy="458787"/>
-          </a:xfrm>
-          <a:prstGeom prst="rect">
-            <a:avLst/>
-          </a:prstGeom>
-        </p:spPr>
-        <p:txBody>
-          <a:bodyPr vert="horz" lIns="91440" tIns="45720" rIns="91440" bIns="45720" rtlCol="0" anchor="b"/>
-          <a:lstStyle>
-            <a:lvl1pPr algn="l">
-              <a:defRPr sz="1200"/>
-            </a:lvl1pPr>
-          </a:lstStyle>
-          <a:p>
-            <a:endParaRPr lang="en-US"/>
-          </a:p>
-        </p:txBody>
-      </p:sp>
-      <p:sp>
-        <p:nvSpPr>
-          <p:cNvPr id="7" name="Slide Number Placeholder 6"/>
-          <p:cNvSpPr>
-            <a:spLocks noGrp="1"/>
-          </p:cNvSpPr>
-          <p:nvPr>
-            <p:ph type="sldNum" sz="quarter" idx="5"/>
-          </p:nvPr>
-        </p:nvSpPr>
-        <p:spPr>
-          <a:xfrm>
-            <a:off x="3884613" y="8685213"/>
-            <a:ext cx="2971800" cy="458787"/>
-          </a:xfrm>
-          <a:prstGeom prst="rect">
-            <a:avLst/>
-          </a:prstGeom>
-        </p:spPr>
-        <p:txBody>
-          <a:bodyPr vert="horz" lIns="91440" tIns="45720" rIns="91440" bIns="45720" rtlCol="0" anchor="b"/>
-          <a:lstStyle>
-            <a:lvl1pPr algn="r">
-              <a:defRPr sz="1200"/>
-            </a:lvl1pPr>
-          </a:lstStyle>
-          <a:p>
-            <a:fld id="{CE5E9CC1-C706-0F49-92D6-E571CC5EEA8F}" type="slidenum">
-              <a:rPr lang="en-US"/>
-              <a:t>‹#›</a:t>
-            </a:fld>
-            <a:endParaRPr lang="en-US"/>
-          </a:p>
-        </p:txBody>
-      </p:sp>
     </p:spTree>
     <p:extLst>
       <p:ext uri="{BB962C8B-B14F-4D97-AF65-F5344CB8AC3E}">
-        <p14:creationId xmlns:p14="http://schemas.microsoft.com/office/powerpoint/2010/main" val="1024086991"/>
+        <p14:creationId xmlns:p14="http://schemas.microsoft.com/office/powerpoint/2010/main" val="3326863577"/>
       </p:ext>
     </p:extLst>
   </p:cSld>
@@ -506,10 +287,6 @@
           <a:bodyPr/>
           <a:lstStyle/>
           <a:p>
-            <a:r>
-              <a:rPr lang="en-US" dirty="0"/>
-              <a:t/>
-            </a:r>
             <a:endParaRPr lang="en-US" dirty="0"/>
           </a:p>
         </p:txBody>
@@ -594,10 +371,6 @@
           <a:bodyPr/>
           <a:lstStyle/>
           <a:p>
-            <a:r>
-              <a:rPr lang="en-US" dirty="0"/>
-              <a:t/>
-            </a:r>
             <a:endParaRPr lang="en-US" dirty="0"/>
           </a:p>
         </p:txBody>
@@ -682,10 +455,6 @@
           <a:bodyPr/>
           <a:lstStyle/>
           <a:p>
-            <a:r>
-              <a:rPr lang="en-US" dirty="0"/>
-              <a:t/>
-            </a:r>
             <a:endParaRPr lang="en-US" dirty="0"/>
           </a:p>
         </p:txBody>
@@ -770,10 +539,6 @@
           <a:bodyPr/>
           <a:lstStyle/>
           <a:p>
-            <a:r>
-              <a:rPr lang="en-US" dirty="0"/>
-              <a:t/>
-            </a:r>
             <a:endParaRPr lang="en-US" dirty="0"/>
           </a:p>
         </p:txBody>
@@ -858,10 +623,6 @@
           <a:bodyPr/>
           <a:lstStyle/>
           <a:p>
-            <a:r>
-              <a:rPr lang="en-US" dirty="0"/>
-              <a:t/>
-            </a:r>
             <a:endParaRPr lang="en-US" dirty="0"/>
           </a:p>
         </p:txBody>
@@ -946,10 +707,6 @@
           <a:bodyPr/>
           <a:lstStyle/>
           <a:p>
-            <a:r>
-              <a:rPr lang="en-US" dirty="0"/>
-              <a:t/>
-            </a:r>
             <a:endParaRPr lang="en-US" dirty="0"/>
           </a:p>
         </p:txBody>
@@ -1034,10 +791,6 @@
           <a:bodyPr/>
           <a:lstStyle/>
           <a:p>
-            <a:r>
-              <a:rPr lang="en-US" dirty="0"/>
-              <a:t/>
-            </a:r>
             <a:endParaRPr lang="en-US" dirty="0"/>
           </a:p>
         </p:txBody>
@@ -1111,6 +864,11 @@
 <file path=ppt/slideMasters/slideMaster1.xml><?xml version="1.0" encoding="utf-8"?>
 <p:sldMaster xmlns:a="http://schemas.openxmlformats.org/drawingml/2006/main" xmlns:r="http://schemas.openxmlformats.org/officeDocument/2006/relationships" xmlns:p="http://schemas.openxmlformats.org/presentationml/2006/main">
   <p:cSld>
+    <p:bg>
+      <p:bgRef idx="1001">
+        <a:schemeClr val="bg1"/>
+      </p:bgRef>
+    </p:bg>
     <p:spTree>
       <p:nvGrpSpPr>
         <p:cNvPr id="1" name=""/>
@@ -1393,6 +1151,7 @@
         <a:solidFill>
           <a:srgbClr val="0B1426"/>
         </a:solidFill>
+        <a:effectLst/>
       </p:bgPr>
     </p:bg>
     <p:spTree>
@@ -1432,7 +1191,7 @@
           <a:bodyPr wrap="square" rtlCol="0" anchor="ctr"/>
           <a:lstStyle/>
           <a:p>
-            <a:pPr indent="0" marL="0">
+            <a:pPr marL="0" indent="0">
               <a:buNone/>
             </a:pPr>
             <a:endParaRPr lang="en-US" dirty="0"/>
@@ -1462,7 +1221,7 @@
           <a:bodyPr wrap="square" rtlCol="0" anchor="ctr"/>
           <a:lstStyle/>
           <a:p>
-            <a:pPr indent="0" marL="0">
+            <a:pPr marL="0" indent="0">
               <a:buNone/>
             </a:pPr>
             <a:endParaRPr lang="en-US" dirty="0"/>
@@ -1491,6 +1250,13 @@
             <a:prstDash val="solid"/>
           </a:ln>
         </p:spPr>
+        <p:txBody>
+          <a:bodyPr/>
+          <a:lstStyle/>
+          <a:p>
+            <a:endParaRPr lang="en-US"/>
+          </a:p>
+        </p:txBody>
       </p:sp>
       <p:sp>
         <p:nvSpPr>
@@ -1514,6 +1280,13 @@
             <a:prstDash val="solid"/>
           </a:ln>
         </p:spPr>
+        <p:txBody>
+          <a:bodyPr/>
+          <a:lstStyle/>
+          <a:p>
+            <a:endParaRPr lang="en-US"/>
+          </a:p>
+        </p:txBody>
       </p:sp>
       <p:sp>
         <p:nvSpPr>
@@ -1536,7 +1309,7 @@
           <a:bodyPr wrap="square" lIns="0" tIns="0" rIns="0" bIns="0" rtlCol="0" anchor="t"/>
           <a:lstStyle/>
           <a:p>
-            <a:pPr algn="l" indent="0" marL="0">
+            <a:pPr marL="0" indent="0" algn="l">
               <a:spcAft>
                 <a:spcPts val="1200"/>
               </a:spcAft>
@@ -1578,7 +1351,7 @@
           <a:bodyPr wrap="square" lIns="0" tIns="0" rIns="0" bIns="0" rtlCol="0" anchor="t"/>
           <a:lstStyle/>
           <a:p>
-            <a:pPr algn="l" indent="0" marL="0">
+            <a:pPr marL="0" indent="0" algn="l">
               <a:lnSpc>
                 <a:spcPts val="4200"/>
               </a:lnSpc>
@@ -1595,39 +1368,27 @@
               </a:rPr>
               <a:t>Beyond </a:t>
             </a:r>
-            <a:pPr algn="l" indent="0" marL="0">
+            <a:r>
+              <a:rPr lang="en-US" sz="4000" b="1" dirty="0">
+                <a:solidFill>
+                  <a:srgbClr val="7C3AED"/>
+                </a:solidFill>
+                <a:latin typeface="Arial" pitchFamily="34" charset="0"/>
+                <a:ea typeface="Arial" pitchFamily="34" charset="-122"/>
+                <a:cs typeface="Arial" pitchFamily="34" charset="-120"/>
+              </a:rPr>
+              <a:t>LangGraph</a:t>
+            </a:r>
+            <a:endParaRPr lang="en-US" sz="4000" dirty="0"/>
+          </a:p>
+          <a:p>
+            <a:pPr marL="0" indent="0" algn="l">
               <a:lnSpc>
                 <a:spcPts val="4200"/>
               </a:lnSpc>
               <a:buNone/>
             </a:pPr>
             <a:r>
-              <a:rPr lang="en-US" sz="4000" b="1" dirty="0">
-                <a:solidFill>
-                  <a:srgbClr val="7C3AED"/>
-                </a:solidFill>
-                <a:latin typeface="Arial" pitchFamily="34" charset="0"/>
-                <a:ea typeface="Arial" pitchFamily="34" charset="-122"/>
-                <a:cs typeface="Arial" pitchFamily="34" charset="-120"/>
-              </a:rPr>
-              <a:t>LangGraph</a:t>
-            </a:r>
-            <a:pPr algn="l" indent="0" marL="0">
-              <a:lnSpc>
-                <a:spcPts val="4200"/>
-              </a:lnSpc>
-              <a:buNone/>
-            </a:pPr>
-            <a:endParaRPr lang="en-US" sz="4000" dirty="0"/>
-          </a:p>
-          <a:p>
-            <a:pPr algn="l" indent="0" marL="0">
-              <a:lnSpc>
-                <a:spcPts val="4200"/>
-              </a:lnSpc>
-              <a:buNone/>
-            </a:pPr>
-            <a:r>
               <a:rPr lang="en-US" sz="4000" dirty="0">
                 <a:solidFill>
                   <a:srgbClr val="F1F5F9"/>
@@ -1665,7 +1426,7 @@
           <a:bodyPr wrap="square" rtlCol="0" anchor="ctr"/>
           <a:lstStyle/>
           <a:p>
-            <a:pPr indent="0" marL="0">
+            <a:pPr marL="0" indent="0">
               <a:buNone/>
             </a:pPr>
             <a:endParaRPr lang="en-US" dirty="0"/>
@@ -1693,7 +1454,7 @@
           <a:bodyPr wrap="square" lIns="0" tIns="0" rIns="0" bIns="0" rtlCol="0" anchor="t"/>
           <a:lstStyle/>
           <a:p>
-            <a:pPr algn="l" indent="0" marL="0">
+            <a:pPr marL="0" indent="0" algn="l">
               <a:lnSpc>
                 <a:spcPts val="1960"/>
               </a:lnSpc>
@@ -1735,7 +1496,7 @@
           <a:bodyPr wrap="square" lIns="0" tIns="0" rIns="0" bIns="0" rtlCol="0" anchor="t"/>
           <a:lstStyle/>
           <a:p>
-            <a:pPr algn="l" indent="0" marL="0">
+            <a:pPr marL="0" indent="0" algn="l">
               <a:spcAft>
                 <a:spcPts val="400"/>
               </a:spcAft>
@@ -1777,7 +1538,7 @@
           <a:bodyPr wrap="square" lIns="0" tIns="0" rIns="0" bIns="0" rtlCol="0" anchor="t"/>
           <a:lstStyle/>
           <a:p>
-            <a:pPr algn="l" indent="0" marL="0">
+            <a:pPr marL="0" indent="0" algn="l">
               <a:buNone/>
             </a:pPr>
             <a:r>
@@ -1818,7 +1579,7 @@
           <a:bodyPr wrap="square" rtlCol="0" anchor="ctr"/>
           <a:lstStyle/>
           <a:p>
-            <a:pPr indent="0" marL="0">
+            <a:pPr marL="0" indent="0">
               <a:buNone/>
             </a:pPr>
             <a:endParaRPr lang="en-US" dirty="0"/>
@@ -1846,7 +1607,7 @@
           <a:bodyPr wrap="square" lIns="0" tIns="0" rIns="0" bIns="0" rtlCol="0" anchor="t"/>
           <a:lstStyle/>
           <a:p>
-            <a:pPr algn="l" indent="0" marL="0">
+            <a:pPr marL="0" indent="0" algn="l">
               <a:spcAft>
                 <a:spcPts val="400"/>
               </a:spcAft>
@@ -1888,7 +1649,7 @@
           <a:bodyPr wrap="square" lIns="0" tIns="0" rIns="0" bIns="0" rtlCol="0" anchor="t"/>
           <a:lstStyle/>
           <a:p>
-            <a:pPr algn="l" indent="0" marL="0">
+            <a:pPr marL="0" indent="0" algn="l">
               <a:buNone/>
             </a:pPr>
             <a:r>
@@ -1929,7 +1690,7 @@
           <a:bodyPr wrap="square" rtlCol="0" anchor="ctr"/>
           <a:lstStyle/>
           <a:p>
-            <a:pPr indent="0" marL="0">
+            <a:pPr marL="0" indent="0">
               <a:buNone/>
             </a:pPr>
             <a:endParaRPr lang="en-US" dirty="0"/>
@@ -1957,7 +1718,7 @@
           <a:bodyPr wrap="square" lIns="0" tIns="0" rIns="0" bIns="0" rtlCol="0" anchor="t"/>
           <a:lstStyle/>
           <a:p>
-            <a:pPr algn="l" indent="0" marL="0">
+            <a:pPr marL="0" indent="0" algn="l">
               <a:spcAft>
                 <a:spcPts val="400"/>
               </a:spcAft>
@@ -1999,7 +1760,7 @@
           <a:bodyPr wrap="square" lIns="0" tIns="0" rIns="0" bIns="0" rtlCol="0" anchor="t"/>
           <a:lstStyle/>
           <a:p>
-            <a:pPr algn="l" indent="0" marL="0">
+            <a:pPr marL="0" indent="0" algn="l">
               <a:buNone/>
             </a:pPr>
             <a:r>
@@ -2038,7 +1799,7 @@
           <a:bodyPr wrap="square" lIns="0" tIns="0" rIns="0" bIns="0" rtlCol="0" anchor="t"/>
           <a:lstStyle/>
           <a:p>
-            <a:pPr algn="l" indent="0" marL="0">
+            <a:pPr marL="0" indent="0" algn="l">
               <a:buNone/>
             </a:pPr>
             <a:r>
@@ -2081,7 +1842,7 @@
           <a:bodyPr wrap="square" rtlCol="0" anchor="ctr"/>
           <a:lstStyle/>
           <a:p>
-            <a:pPr indent="0" marL="0">
+            <a:pPr marL="0" indent="0">
               <a:buNone/>
             </a:pPr>
             <a:endParaRPr lang="en-US" dirty="0"/>
@@ -2109,7 +1870,7 @@
           <a:bodyPr wrap="square" lIns="0" tIns="0" rIns="0" bIns="0" rtlCol="0" anchor="t"/>
           <a:lstStyle/>
           <a:p>
-            <a:pPr algn="l" indent="0" marL="0">
+            <a:pPr marL="0" indent="0" algn="l">
               <a:buNone/>
             </a:pPr>
             <a:r>
@@ -2143,6 +1904,7 @@
         <a:solidFill>
           <a:srgbClr val="F8FAFC"/>
         </a:solidFill>
+        <a:effectLst/>
       </p:bgPr>
     </p:bg>
     <p:spTree>
@@ -2180,7 +1942,7 @@
           <a:bodyPr wrap="square" lIns="0" tIns="0" rIns="0" bIns="0" rtlCol="0" anchor="t"/>
           <a:lstStyle/>
           <a:p>
-            <a:pPr algn="l" indent="0" marL="0">
+            <a:pPr marL="0" indent="0" algn="l">
               <a:buNone/>
             </a:pPr>
             <a:r>
@@ -2221,7 +1983,7 @@
           <a:bodyPr wrap="square" rtlCol="0" anchor="ctr"/>
           <a:lstStyle/>
           <a:p>
-            <a:pPr indent="0" marL="0">
+            <a:pPr marL="0" indent="0">
               <a:buNone/>
             </a:pPr>
             <a:endParaRPr lang="en-US" dirty="0"/>
@@ -2249,7 +2011,7 @@
           <a:bodyPr wrap="square" lIns="0" tIns="0" rIns="0" bIns="0" rtlCol="0" anchor="t"/>
           <a:lstStyle/>
           <a:p>
-            <a:pPr algn="l" indent="0" marL="0">
+            <a:pPr marL="0" indent="0" algn="l">
               <a:buNone/>
             </a:pPr>
             <a:r>
@@ -2288,7 +2050,7 @@
           <a:bodyPr wrap="square" lIns="0" tIns="0" rIns="0" bIns="0" rtlCol="0" anchor="t"/>
           <a:lstStyle/>
           <a:p>
-            <a:pPr algn="l" indent="0" marL="0">
+            <a:pPr marL="0" indent="0" algn="l">
               <a:lnSpc>
                 <a:spcPts val="3680"/>
               </a:lnSpc>
@@ -2333,7 +2095,7 @@
           <a:bodyPr wrap="square" lIns="0" tIns="0" rIns="0" bIns="0" rtlCol="0" anchor="t"/>
           <a:lstStyle/>
           <a:p>
-            <a:pPr algn="l" indent="0" marL="0">
+            <a:pPr marL="0" indent="0" algn="l">
               <a:lnSpc>
                 <a:spcPts val="1820"/>
               </a:lnSpc>
@@ -2375,7 +2137,7 @@
           <a:bodyPr wrap="square" lIns="0" tIns="0" rIns="0" bIns="0" rtlCol="0" anchor="t"/>
           <a:lstStyle/>
           <a:p>
-            <a:pPr algn="l" indent="0" marL="0">
+            <a:pPr marL="0" indent="0" algn="l">
               <a:spcAft>
                 <a:spcPts val="1200"/>
               </a:spcAft>
@@ -2417,7 +2179,7 @@
           <a:bodyPr wrap="square" lIns="0" tIns="0" rIns="0" bIns="0" rtlCol="0" anchor="t"/>
           <a:lstStyle/>
           <a:p>
-            <a:pPr algn="l" indent="0" marL="0">
+            <a:pPr marL="0" indent="0" algn="l">
               <a:lnSpc>
                 <a:spcPts val="1860"/>
               </a:lnSpc>
@@ -2462,7 +2224,7 @@
           <a:bodyPr wrap="square" lIns="0" tIns="0" rIns="0" bIns="0" rtlCol="0" anchor="t"/>
           <a:lstStyle/>
           <a:p>
-            <a:pPr algn="l" indent="0" marL="0">
+            <a:pPr marL="0" indent="0" algn="l">
               <a:lnSpc>
                 <a:spcPts val="1860"/>
               </a:lnSpc>
@@ -2482,15 +2244,6 @@
               </a:rPr>
               <a:t>The naive approach: build it directly in LangGraph using </a:t>
             </a:r>
-            <a:pPr algn="l" indent="0" marL="0">
-              <a:lnSpc>
-                <a:spcPts val="1860"/>
-              </a:lnSpc>
-              <a:spcAft>
-                <a:spcPts val="1200"/>
-              </a:spcAft>
-              <a:buNone/>
-            </a:pPr>
             <a:r>
               <a:rPr lang="en-US" sz="1200" b="1" dirty="0">
                 <a:solidFill>
@@ -2502,15 +2255,6 @@
               </a:rPr>
               <a:t>StateGraph</a:t>
             </a:r>
-            <a:pPr algn="l" indent="0" marL="0">
-              <a:lnSpc>
-                <a:spcPts val="1860"/>
-              </a:lnSpc>
-              <a:spcAft>
-                <a:spcPts val="1200"/>
-              </a:spcAft>
-              <a:buNone/>
-            </a:pPr>
             <a:r>
               <a:rPr lang="en-US" sz="1200" dirty="0">
                 <a:solidFill>
@@ -2551,7 +2295,7 @@
           <a:bodyPr wrap="square" rtlCol="0" anchor="ctr"/>
           <a:lstStyle/>
           <a:p>
-            <a:pPr indent="0" marL="0">
+            <a:pPr marL="0" indent="0">
               <a:buNone/>
             </a:pPr>
             <a:endParaRPr lang="en-US" dirty="0"/>
@@ -2579,7 +2323,7 @@
           <a:bodyPr wrap="square" lIns="0" tIns="0" rIns="0" bIns="0" rtlCol="0" anchor="t"/>
           <a:lstStyle/>
           <a:p>
-            <a:pPr algn="l" indent="0" marL="0">
+            <a:pPr marL="0" indent="0" algn="l">
               <a:spcAft>
                 <a:spcPts val="1200"/>
               </a:spcAft>
@@ -2621,7 +2365,7 @@
           <a:bodyPr wrap="square" lIns="0" tIns="0" rIns="0" bIns="0" rtlCol="0" anchor="t"/>
           <a:lstStyle/>
           <a:p>
-            <a:pPr algn="l" marL="342900" indent="-342900">
+            <a:pPr marL="342900" indent="-342900" algn="l">
               <a:lnSpc>
                 <a:spcPts val="1650"/>
               </a:lnSpc>
@@ -2645,7 +2389,7 @@
             <a:endParaRPr lang="en-US" sz="1100" dirty="0"/>
           </a:p>
           <a:p>
-            <a:pPr algn="l" marL="342900" indent="-342900">
+            <a:pPr marL="342900" indent="-342900" algn="l">
               <a:lnSpc>
                 <a:spcPts val="1650"/>
               </a:lnSpc>
@@ -2669,7 +2413,7 @@
             <a:endParaRPr lang="en-US" sz="1100" dirty="0"/>
           </a:p>
           <a:p>
-            <a:pPr algn="l" marL="342900" indent="-342900">
+            <a:pPr marL="342900" indent="-342900" algn="l">
               <a:lnSpc>
                 <a:spcPts val="1650"/>
               </a:lnSpc>
@@ -2693,7 +2437,7 @@
             <a:endParaRPr lang="en-US" sz="1100" dirty="0"/>
           </a:p>
           <a:p>
-            <a:pPr algn="l" marL="342900" indent="-342900">
+            <a:pPr marL="342900" indent="-342900" algn="l">
               <a:lnSpc>
                 <a:spcPts val="1650"/>
               </a:lnSpc>
@@ -2717,7 +2461,7 @@
             <a:endParaRPr lang="en-US" sz="1100" dirty="0"/>
           </a:p>
           <a:p>
-            <a:pPr algn="l" marL="342900" indent="-342900">
+            <a:pPr marL="342900" indent="-342900" algn="l">
               <a:lnSpc>
                 <a:spcPts val="1650"/>
               </a:lnSpc>
@@ -2765,7 +2509,7 @@
           <a:bodyPr wrap="square" rtlCol="0" anchor="ctr"/>
           <a:lstStyle/>
           <a:p>
-            <a:pPr indent="0" marL="0">
+            <a:pPr marL="0" indent="0">
               <a:buNone/>
             </a:pPr>
             <a:endParaRPr lang="en-US" dirty="0"/>
@@ -2788,6 +2532,7 @@
         <a:solidFill>
           <a:srgbClr val="F8FAFC"/>
         </a:solidFill>
+        <a:effectLst/>
       </p:bgPr>
     </p:bg>
     <p:spTree>
@@ -2825,7 +2570,7 @@
           <a:bodyPr wrap="square" lIns="0" tIns="0" rIns="0" bIns="0" rtlCol="0" anchor="t"/>
           <a:lstStyle/>
           <a:p>
-            <a:pPr algn="l" indent="0" marL="0">
+            <a:pPr marL="0" indent="0" algn="l">
               <a:buNone/>
             </a:pPr>
             <a:r>
@@ -2866,7 +2611,7 @@
           <a:bodyPr wrap="square" rtlCol="0" anchor="ctr"/>
           <a:lstStyle/>
           <a:p>
-            <a:pPr indent="0" marL="0">
+            <a:pPr marL="0" indent="0">
               <a:buNone/>
             </a:pPr>
             <a:endParaRPr lang="en-US" dirty="0"/>
@@ -2894,7 +2639,7 @@
           <a:bodyPr wrap="square" lIns="0" tIns="0" rIns="0" bIns="0" rtlCol="0" anchor="t"/>
           <a:lstStyle/>
           <a:p>
-            <a:pPr algn="l" indent="0" marL="0">
+            <a:pPr marL="0" indent="0" algn="l">
               <a:buNone/>
             </a:pPr>
             <a:r>
@@ -2933,7 +2678,7 @@
           <a:bodyPr wrap="square" lIns="0" tIns="0" rIns="0" bIns="0" rtlCol="0" anchor="t"/>
           <a:lstStyle/>
           <a:p>
-            <a:pPr algn="l" indent="0" marL="0">
+            <a:pPr marL="0" indent="0" algn="l">
               <a:lnSpc>
                 <a:spcPts val="3220"/>
               </a:lnSpc>
@@ -2978,7 +2723,7 @@
           <a:bodyPr wrap="square" lIns="0" tIns="0" rIns="0" bIns="0" rtlCol="0" anchor="t"/>
           <a:lstStyle/>
           <a:p>
-            <a:pPr algn="l" indent="0" marL="0">
+            <a:pPr marL="0" indent="0" algn="l">
               <a:buNone/>
             </a:pPr>
             <a:r>
@@ -3015,8 +2760,8 @@
           </a:solidFill>
           <a:ln/>
           <a:effectLst>
-            <a:outerShdw sx="100000" sy="100000" kx="0" ky="0" algn="bl" rotWithShape="0" blurRad="57150" dist="21299" dir="3780000">
-              <a:srgbClr val="0f172a">
+            <a:outerShdw blurRad="57150" dist="21299" dir="3780000" algn="bl" rotWithShape="0">
+              <a:srgbClr val="0F172A">
                 <a:alpha val="8000"/>
               </a:srgbClr>
             </a:outerShdw>
@@ -3026,7 +2771,7 @@
           <a:bodyPr wrap="square" rtlCol="0" anchor="ctr"/>
           <a:lstStyle/>
           <a:p>
-            <a:pPr indent="0" marL="0">
+            <a:pPr marL="0" indent="0">
               <a:buNone/>
             </a:pPr>
             <a:endParaRPr lang="en-US" dirty="0"/>
@@ -3055,6 +2800,13 @@
             <a:prstDash val="solid"/>
           </a:ln>
         </p:spPr>
+        <p:txBody>
+          <a:bodyPr/>
+          <a:lstStyle/>
+          <a:p>
+            <a:endParaRPr lang="en-US"/>
+          </a:p>
+        </p:txBody>
       </p:sp>
       <p:sp>
         <p:nvSpPr>
@@ -3077,7 +2829,7 @@
           <a:bodyPr wrap="square" lIns="0" tIns="0" rIns="0" bIns="0" rtlCol="0" anchor="t"/>
           <a:lstStyle/>
           <a:p>
-            <a:pPr algn="l" indent="0" marL="0">
+            <a:pPr marL="0" indent="0" algn="l">
               <a:spcAft>
                 <a:spcPts val="300"/>
               </a:spcAft>
@@ -3119,7 +2871,7 @@
           <a:bodyPr wrap="square" lIns="0" tIns="0" rIns="0" bIns="0" rtlCol="0" anchor="t"/>
           <a:lstStyle/>
           <a:p>
-            <a:pPr algn="l" indent="0" marL="0">
+            <a:pPr marL="0" indent="0" algn="l">
               <a:lnSpc>
                 <a:spcPts val="1380"/>
               </a:lnSpc>
@@ -3164,7 +2916,7 @@
           <a:bodyPr wrap="square" lIns="0" tIns="0" rIns="0" bIns="0" rtlCol="0" anchor="t"/>
           <a:lstStyle/>
           <a:p>
-            <a:pPr algn="l" indent="0" marL="0">
+            <a:pPr marL="0" indent="0" algn="l">
               <a:lnSpc>
                 <a:spcPts val="1215"/>
               </a:lnSpc>
@@ -3204,8 +2956,8 @@
           </a:solidFill>
           <a:ln/>
           <a:effectLst>
-            <a:outerShdw sx="100000" sy="100000" kx="0" ky="0" algn="bl" rotWithShape="0" blurRad="57150" dist="21299" dir="3780000">
-              <a:srgbClr val="0f172a">
+            <a:outerShdw blurRad="57150" dist="21299" dir="3780000" algn="bl" rotWithShape="0">
+              <a:srgbClr val="0F172A">
                 <a:alpha val="8000"/>
               </a:srgbClr>
             </a:outerShdw>
@@ -3215,7 +2967,7 @@
           <a:bodyPr wrap="square" rtlCol="0" anchor="ctr"/>
           <a:lstStyle/>
           <a:p>
-            <a:pPr indent="0" marL="0">
+            <a:pPr marL="0" indent="0">
               <a:buNone/>
             </a:pPr>
             <a:endParaRPr lang="en-US" dirty="0"/>
@@ -3244,6 +2996,13 @@
             <a:prstDash val="solid"/>
           </a:ln>
         </p:spPr>
+        <p:txBody>
+          <a:bodyPr/>
+          <a:lstStyle/>
+          <a:p>
+            <a:endParaRPr lang="en-US"/>
+          </a:p>
+        </p:txBody>
       </p:sp>
       <p:sp>
         <p:nvSpPr>
@@ -3266,7 +3025,7 @@
           <a:bodyPr wrap="square" lIns="0" tIns="0" rIns="0" bIns="0" rtlCol="0" anchor="t"/>
           <a:lstStyle/>
           <a:p>
-            <a:pPr algn="l" indent="0" marL="0">
+            <a:pPr marL="0" indent="0" algn="l">
               <a:spcAft>
                 <a:spcPts val="300"/>
               </a:spcAft>
@@ -3308,7 +3067,7 @@
           <a:bodyPr wrap="square" lIns="0" tIns="0" rIns="0" bIns="0" rtlCol="0" anchor="t"/>
           <a:lstStyle/>
           <a:p>
-            <a:pPr algn="l" indent="0" marL="0">
+            <a:pPr marL="0" indent="0" algn="l">
               <a:lnSpc>
                 <a:spcPts val="1380"/>
               </a:lnSpc>
@@ -3353,7 +3112,7 @@
           <a:bodyPr wrap="square" lIns="0" tIns="0" rIns="0" bIns="0" rtlCol="0" anchor="t"/>
           <a:lstStyle/>
           <a:p>
-            <a:pPr algn="l" indent="0" marL="0">
+            <a:pPr marL="0" indent="0" algn="l">
               <a:lnSpc>
                 <a:spcPts val="1215"/>
               </a:lnSpc>
@@ -3393,8 +3152,8 @@
           </a:solidFill>
           <a:ln/>
           <a:effectLst>
-            <a:outerShdw sx="100000" sy="100000" kx="0" ky="0" algn="bl" rotWithShape="0" blurRad="57150" dist="21299" dir="3780000">
-              <a:srgbClr val="0f172a">
+            <a:outerShdw blurRad="57150" dist="21299" dir="3780000" algn="bl" rotWithShape="0">
+              <a:srgbClr val="0F172A">
                 <a:alpha val="8000"/>
               </a:srgbClr>
             </a:outerShdw>
@@ -3404,7 +3163,7 @@
           <a:bodyPr wrap="square" rtlCol="0" anchor="ctr"/>
           <a:lstStyle/>
           <a:p>
-            <a:pPr indent="0" marL="0">
+            <a:pPr marL="0" indent="0">
               <a:buNone/>
             </a:pPr>
             <a:endParaRPr lang="en-US" dirty="0"/>
@@ -3433,6 +3192,13 @@
             <a:prstDash val="solid"/>
           </a:ln>
         </p:spPr>
+        <p:txBody>
+          <a:bodyPr/>
+          <a:lstStyle/>
+          <a:p>
+            <a:endParaRPr lang="en-US"/>
+          </a:p>
+        </p:txBody>
       </p:sp>
       <p:sp>
         <p:nvSpPr>
@@ -3455,7 +3221,7 @@
           <a:bodyPr wrap="square" lIns="0" tIns="0" rIns="0" bIns="0" rtlCol="0" anchor="t"/>
           <a:lstStyle/>
           <a:p>
-            <a:pPr algn="l" indent="0" marL="0">
+            <a:pPr marL="0" indent="0" algn="l">
               <a:spcAft>
                 <a:spcPts val="300"/>
               </a:spcAft>
@@ -3497,7 +3263,7 @@
           <a:bodyPr wrap="square" lIns="0" tIns="0" rIns="0" bIns="0" rtlCol="0" anchor="t"/>
           <a:lstStyle/>
           <a:p>
-            <a:pPr algn="l" indent="0" marL="0">
+            <a:pPr marL="0" indent="0" algn="l">
               <a:lnSpc>
                 <a:spcPts val="1380"/>
               </a:lnSpc>
@@ -3542,7 +3308,7 @@
           <a:bodyPr wrap="square" lIns="0" tIns="0" rIns="0" bIns="0" rtlCol="0" anchor="t"/>
           <a:lstStyle/>
           <a:p>
-            <a:pPr algn="l" indent="0" marL="0">
+            <a:pPr marL="0" indent="0" algn="l">
               <a:lnSpc>
                 <a:spcPts val="1215"/>
               </a:lnSpc>
@@ -3582,8 +3348,8 @@
           </a:solidFill>
           <a:ln/>
           <a:effectLst>
-            <a:outerShdw sx="100000" sy="100000" kx="0" ky="0" algn="bl" rotWithShape="0" blurRad="57150" dist="21299" dir="3780000">
-              <a:srgbClr val="0f172a">
+            <a:outerShdw blurRad="57150" dist="21299" dir="3780000" algn="bl" rotWithShape="0">
+              <a:srgbClr val="0F172A">
                 <a:alpha val="8000"/>
               </a:srgbClr>
             </a:outerShdw>
@@ -3593,7 +3359,7 @@
           <a:bodyPr wrap="square" rtlCol="0" anchor="ctr"/>
           <a:lstStyle/>
           <a:p>
-            <a:pPr indent="0" marL="0">
+            <a:pPr marL="0" indent="0">
               <a:buNone/>
             </a:pPr>
             <a:endParaRPr lang="en-US" dirty="0"/>
@@ -3622,6 +3388,13 @@
             <a:prstDash val="solid"/>
           </a:ln>
         </p:spPr>
+        <p:txBody>
+          <a:bodyPr/>
+          <a:lstStyle/>
+          <a:p>
+            <a:endParaRPr lang="en-US"/>
+          </a:p>
+        </p:txBody>
       </p:sp>
       <p:sp>
         <p:nvSpPr>
@@ -3644,7 +3417,7 @@
           <a:bodyPr wrap="square" lIns="0" tIns="0" rIns="0" bIns="0" rtlCol="0" anchor="t"/>
           <a:lstStyle/>
           <a:p>
-            <a:pPr algn="l" indent="0" marL="0">
+            <a:pPr marL="0" indent="0" algn="l">
               <a:spcAft>
                 <a:spcPts val="300"/>
               </a:spcAft>
@@ -3686,7 +3459,7 @@
           <a:bodyPr wrap="square" lIns="0" tIns="0" rIns="0" bIns="0" rtlCol="0" anchor="t"/>
           <a:lstStyle/>
           <a:p>
-            <a:pPr algn="l" indent="0" marL="0">
+            <a:pPr marL="0" indent="0" algn="l">
               <a:lnSpc>
                 <a:spcPts val="1380"/>
               </a:lnSpc>
@@ -3731,7 +3504,7 @@
           <a:bodyPr wrap="square" lIns="0" tIns="0" rIns="0" bIns="0" rtlCol="0" anchor="t"/>
           <a:lstStyle/>
           <a:p>
-            <a:pPr algn="l" indent="0" marL="0">
+            <a:pPr marL="0" indent="0" algn="l">
               <a:lnSpc>
                 <a:spcPts val="1215"/>
               </a:lnSpc>
@@ -3771,8 +3544,8 @@
           </a:solidFill>
           <a:ln/>
           <a:effectLst>
-            <a:outerShdw sx="100000" sy="100000" kx="0" ky="0" algn="bl" rotWithShape="0" blurRad="57150" dist="21299" dir="3780000">
-              <a:srgbClr val="0f172a">
+            <a:outerShdw blurRad="57150" dist="21299" dir="3780000" algn="bl" rotWithShape="0">
+              <a:srgbClr val="0F172A">
                 <a:alpha val="8000"/>
               </a:srgbClr>
             </a:outerShdw>
@@ -3782,7 +3555,7 @@
           <a:bodyPr wrap="square" rtlCol="0" anchor="ctr"/>
           <a:lstStyle/>
           <a:p>
-            <a:pPr indent="0" marL="0">
+            <a:pPr marL="0" indent="0">
               <a:buNone/>
             </a:pPr>
             <a:endParaRPr lang="en-US" dirty="0"/>
@@ -3811,6 +3584,13 @@
             <a:prstDash val="solid"/>
           </a:ln>
         </p:spPr>
+        <p:txBody>
+          <a:bodyPr/>
+          <a:lstStyle/>
+          <a:p>
+            <a:endParaRPr lang="en-US"/>
+          </a:p>
+        </p:txBody>
       </p:sp>
       <p:sp>
         <p:nvSpPr>
@@ -3833,7 +3613,7 @@
           <a:bodyPr wrap="square" lIns="0" tIns="0" rIns="0" bIns="0" rtlCol="0" anchor="t"/>
           <a:lstStyle/>
           <a:p>
-            <a:pPr algn="l" indent="0" marL="0">
+            <a:pPr marL="0" indent="0" algn="l">
               <a:spcAft>
                 <a:spcPts val="300"/>
               </a:spcAft>
@@ -3875,7 +3655,7 @@
           <a:bodyPr wrap="square" lIns="0" tIns="0" rIns="0" bIns="0" rtlCol="0" anchor="t"/>
           <a:lstStyle/>
           <a:p>
-            <a:pPr algn="l" indent="0" marL="0">
+            <a:pPr marL="0" indent="0" algn="l">
               <a:lnSpc>
                 <a:spcPts val="1380"/>
               </a:lnSpc>
@@ -3920,7 +3700,7 @@
           <a:bodyPr wrap="square" lIns="0" tIns="0" rIns="0" bIns="0" rtlCol="0" anchor="t"/>
           <a:lstStyle/>
           <a:p>
-            <a:pPr algn="l" indent="0" marL="0">
+            <a:pPr marL="0" indent="0" algn="l">
               <a:lnSpc>
                 <a:spcPts val="1215"/>
               </a:lnSpc>
@@ -3960,8 +3740,8 @@
           </a:solidFill>
           <a:ln/>
           <a:effectLst>
-            <a:outerShdw sx="100000" sy="100000" kx="0" ky="0" algn="bl" rotWithShape="0" blurRad="57150" dist="21299" dir="3780000">
-              <a:srgbClr val="0f172a">
+            <a:outerShdw blurRad="57150" dist="21299" dir="3780000" algn="bl" rotWithShape="0">
+              <a:srgbClr val="0F172A">
                 <a:alpha val="8000"/>
               </a:srgbClr>
             </a:outerShdw>
@@ -3971,7 +3751,7 @@
           <a:bodyPr wrap="square" rtlCol="0" anchor="ctr"/>
           <a:lstStyle/>
           <a:p>
-            <a:pPr indent="0" marL="0">
+            <a:pPr marL="0" indent="0">
               <a:buNone/>
             </a:pPr>
             <a:endParaRPr lang="en-US" dirty="0"/>
@@ -4000,6 +3780,13 @@
             <a:prstDash val="solid"/>
           </a:ln>
         </p:spPr>
+        <p:txBody>
+          <a:bodyPr/>
+          <a:lstStyle/>
+          <a:p>
+            <a:endParaRPr lang="en-US"/>
+          </a:p>
+        </p:txBody>
       </p:sp>
       <p:sp>
         <p:nvSpPr>
@@ -4022,7 +3809,7 @@
           <a:bodyPr wrap="square" lIns="0" tIns="0" rIns="0" bIns="0" rtlCol="0" anchor="t"/>
           <a:lstStyle/>
           <a:p>
-            <a:pPr algn="l" indent="0" marL="0">
+            <a:pPr marL="0" indent="0" algn="l">
               <a:spcAft>
                 <a:spcPts val="300"/>
               </a:spcAft>
@@ -4064,7 +3851,7 @@
           <a:bodyPr wrap="square" lIns="0" tIns="0" rIns="0" bIns="0" rtlCol="0" anchor="t"/>
           <a:lstStyle/>
           <a:p>
-            <a:pPr algn="l" indent="0" marL="0">
+            <a:pPr marL="0" indent="0" algn="l">
               <a:lnSpc>
                 <a:spcPts val="1380"/>
               </a:lnSpc>
@@ -4109,7 +3896,7 @@
           <a:bodyPr wrap="square" lIns="0" tIns="0" rIns="0" bIns="0" rtlCol="0" anchor="t"/>
           <a:lstStyle/>
           <a:p>
-            <a:pPr algn="l" indent="0" marL="0">
+            <a:pPr marL="0" indent="0" algn="l">
               <a:lnSpc>
                 <a:spcPts val="1215"/>
               </a:lnSpc>
@@ -4153,7 +3940,7 @@
           <a:bodyPr wrap="square" rtlCol="0" anchor="ctr"/>
           <a:lstStyle/>
           <a:p>
-            <a:pPr indent="0" marL="0">
+            <a:pPr marL="0" indent="0">
               <a:buNone/>
             </a:pPr>
             <a:endParaRPr lang="en-US" dirty="0"/>
@@ -4176,6 +3963,7 @@
         <a:solidFill>
           <a:srgbClr val="0B1426"/>
         </a:solidFill>
+        <a:effectLst/>
       </p:bgPr>
     </p:bg>
     <p:spTree>
@@ -4213,7 +4001,7 @@
           <a:bodyPr wrap="square" lIns="0" tIns="0" rIns="0" bIns="0" rtlCol="0" anchor="t"/>
           <a:lstStyle/>
           <a:p>
-            <a:pPr algn="l" indent="0" marL="0">
+            <a:pPr marL="0" indent="0" algn="l">
               <a:buNone/>
             </a:pPr>
             <a:r>
@@ -4254,7 +4042,7 @@
           <a:bodyPr wrap="square" rtlCol="0" anchor="ctr"/>
           <a:lstStyle/>
           <a:p>
-            <a:pPr indent="0" marL="0">
+            <a:pPr marL="0" indent="0">
               <a:buNone/>
             </a:pPr>
             <a:endParaRPr lang="en-US" dirty="0"/>
@@ -4282,7 +4070,7 @@
           <a:bodyPr wrap="square" lIns="0" tIns="0" rIns="0" bIns="0" rtlCol="0" anchor="t"/>
           <a:lstStyle/>
           <a:p>
-            <a:pPr algn="l" indent="0" marL="0">
+            <a:pPr marL="0" indent="0" algn="l">
               <a:buNone/>
             </a:pPr>
             <a:r>
@@ -4321,7 +4109,7 @@
           <a:bodyPr wrap="square" lIns="0" tIns="0" rIns="0" bIns="0" rtlCol="0" anchor="t"/>
           <a:lstStyle/>
           <a:p>
-            <a:pPr algn="l" indent="0" marL="0">
+            <a:pPr marL="0" indent="0" algn="l">
               <a:lnSpc>
                 <a:spcPts val="3450"/>
               </a:lnSpc>
@@ -4341,15 +4129,6 @@
               </a:rPr>
               <a:t>Enter </a:t>
             </a:r>
-            <a:pPr algn="l" indent="0" marL="0">
-              <a:lnSpc>
-                <a:spcPts val="3450"/>
-              </a:lnSpc>
-              <a:spcAft>
-                <a:spcPts val="800"/>
-              </a:spcAft>
-              <a:buNone/>
-            </a:pPr>
             <a:r>
               <a:rPr lang="en-US" sz="3000" b="1" dirty="0">
                 <a:solidFill>
@@ -4361,15 +4140,6 @@
               </a:rPr>
               <a:t>Deep Agents</a:t>
             </a:r>
-            <a:pPr algn="l" indent="0" marL="0">
-              <a:lnSpc>
-                <a:spcPts val="3450"/>
-              </a:lnSpc>
-              <a:spcAft>
-                <a:spcPts val="800"/>
-              </a:spcAft>
-              <a:buNone/>
-            </a:pPr>
             <a:r>
               <a:rPr lang="en-US" sz="3000" dirty="0">
                 <a:solidFill>
@@ -4393,7 +4163,7 @@
         </p:nvSpPr>
         <p:spPr>
           <a:xfrm>
-            <a:off x="507950" y="1803202"/>
+            <a:off x="426745" y="1708161"/>
             <a:ext cx="8290509" cy="461963"/>
           </a:xfrm>
           <a:prstGeom prst="rect">
@@ -4406,7 +4176,7 @@
           <a:bodyPr wrap="square" lIns="0" tIns="0" rIns="0" bIns="0" rtlCol="0" anchor="t"/>
           <a:lstStyle/>
           <a:p>
-            <a:pPr algn="l" indent="0" marL="0">
+            <a:pPr marL="0" indent="0" algn="l">
               <a:lnSpc>
                 <a:spcPts val="1820"/>
               </a:lnSpc>
@@ -4435,7 +4205,7 @@
         </p:nvSpPr>
         <p:spPr>
           <a:xfrm>
-            <a:off x="507950" y="1905000"/>
+            <a:off x="507950" y="2287916"/>
             <a:ext cx="8734276" cy="990302"/>
           </a:xfrm>
           <a:prstGeom prst="rect">
@@ -4450,7 +4220,7 @@
           <a:bodyPr wrap="square" rtlCol="0" anchor="ctr"/>
           <a:lstStyle/>
           <a:p>
-            <a:pPr indent="0" marL="0">
+            <a:pPr marL="0" indent="0">
               <a:buNone/>
             </a:pPr>
             <a:endParaRPr lang="en-US" dirty="0"/>
@@ -4465,8 +4235,8 @@
         </p:nvSpPr>
         <p:spPr>
           <a:xfrm>
-            <a:off x="531763" y="1905000"/>
-            <a:ext cx="0" cy="990302"/>
+            <a:off x="507950" y="2271730"/>
+            <a:ext cx="23813" cy="623571"/>
           </a:xfrm>
           <a:prstGeom prst="line">
             <a:avLst/>
@@ -4479,6 +4249,13 @@
             <a:prstDash val="solid"/>
           </a:ln>
         </p:spPr>
+        <p:txBody>
+          <a:bodyPr/>
+          <a:lstStyle/>
+          <a:p>
+            <a:endParaRPr lang="en-US"/>
+          </a:p>
+        </p:txBody>
       </p:sp>
       <p:sp>
         <p:nvSpPr>
@@ -4501,7 +4278,7 @@
           <a:bodyPr wrap="square" lIns="0" tIns="0" rIns="0" bIns="0" rtlCol="0" anchor="t"/>
           <a:lstStyle/>
           <a:p>
-            <a:pPr algn="l" indent="0" marL="0">
+            <a:pPr marL="0" indent="0" algn="l">
               <a:buNone/>
             </a:pPr>
             <a:r>
@@ -4515,9 +4292,6 @@
               </a:rPr>
               <a:t>deepagents</a:t>
             </a:r>
-            <a:pPr algn="l" indent="0" marL="0">
-              <a:buNone/>
-            </a:pPr>
             <a:r>
               <a:rPr lang="en-US" sz="1400" dirty="0">
                 <a:solidFill>
@@ -4529,9 +4303,6 @@
               </a:rPr>
               <a:t> </a:t>
             </a:r>
-            <a:pPr algn="l" indent="0" marL="0">
-              <a:buNone/>
-            </a:pPr>
             <a:r>
               <a:rPr lang="en-US" sz="1400" b="1" dirty="0">
                 <a:solidFill>
@@ -4543,9 +4314,6 @@
               </a:rPr>
               <a:t>=</a:t>
             </a:r>
-            <a:pPr algn="l" indent="0" marL="0">
-              <a:buNone/>
-            </a:pPr>
             <a:r>
               <a:rPr lang="en-US" sz="1400" dirty="0">
                 <a:solidFill>
@@ -4557,9 +4325,6 @@
               </a:rPr>
               <a:t> LangGraph </a:t>
             </a:r>
-            <a:pPr algn="l" indent="0" marL="0">
-              <a:buNone/>
-            </a:pPr>
             <a:r>
               <a:rPr lang="en-US" sz="1400" b="1" dirty="0">
                 <a:solidFill>
@@ -4571,9 +4336,6 @@
               </a:rPr>
               <a:t>+</a:t>
             </a:r>
-            <a:pPr algn="l" indent="0" marL="0">
-              <a:buNone/>
-            </a:pPr>
             <a:r>
               <a:rPr lang="en-US" sz="1400" dirty="0">
                 <a:solidFill>
@@ -4585,9 +4347,6 @@
               </a:rPr>
               <a:t> Planning </a:t>
             </a:r>
-            <a:pPr algn="l" indent="0" marL="0">
-              <a:buNone/>
-            </a:pPr>
             <a:r>
               <a:rPr lang="en-US" sz="1400" b="1" dirty="0">
                 <a:solidFill>
@@ -4599,9 +4358,6 @@
               </a:rPr>
               <a:t>+</a:t>
             </a:r>
-            <a:pPr algn="l" indent="0" marL="0">
-              <a:buNone/>
-            </a:pPr>
             <a:r>
               <a:rPr lang="en-US" sz="1400" dirty="0">
                 <a:solidFill>
@@ -4613,9 +4369,6 @@
               </a:rPr>
               <a:t> Virtual FS </a:t>
             </a:r>
-            <a:pPr algn="l" indent="0" marL="0">
-              <a:buNone/>
-            </a:pPr>
             <a:r>
               <a:rPr lang="en-US" sz="1400" b="1" dirty="0">
                 <a:solidFill>
@@ -4627,9 +4380,6 @@
               </a:rPr>
               <a:t>+</a:t>
             </a:r>
-            <a:pPr algn="l" indent="0" marL="0">
-              <a:buNone/>
-            </a:pPr>
             <a:r>
               <a:rPr lang="en-US" sz="1400" dirty="0">
                 <a:solidFill>
@@ -4641,9 +4391,6 @@
               </a:rPr>
               <a:t> Subagents </a:t>
             </a:r>
-            <a:pPr algn="l" indent="0" marL="0">
-              <a:buNone/>
-            </a:pPr>
             <a:r>
               <a:rPr lang="en-US" sz="1400" b="1" dirty="0">
                 <a:solidFill>
@@ -4655,9 +4402,6 @@
               </a:rPr>
               <a:t>+</a:t>
             </a:r>
-            <a:pPr algn="l" indent="0" marL="0">
-              <a:buNone/>
-            </a:pPr>
             <a:r>
               <a:rPr lang="en-US" sz="1400" dirty="0">
                 <a:solidFill>
@@ -4696,7 +4440,7 @@
           <a:bodyPr wrap="square" rtlCol="0" anchor="ctr"/>
           <a:lstStyle/>
           <a:p>
-            <a:pPr indent="0" marL="0">
+            <a:pPr marL="0" indent="0">
               <a:buNone/>
             </a:pPr>
             <a:endParaRPr lang="en-US" dirty="0"/>
@@ -4725,6 +4469,13 @@
             <a:prstDash val="solid"/>
           </a:ln>
         </p:spPr>
+        <p:txBody>
+          <a:bodyPr/>
+          <a:lstStyle/>
+          <a:p>
+            <a:endParaRPr lang="en-US"/>
+          </a:p>
+        </p:txBody>
       </p:sp>
       <p:sp>
         <p:nvSpPr>
@@ -4747,7 +4498,7 @@
           <a:bodyPr wrap="square" lIns="0" tIns="0" rIns="0" bIns="0" rtlCol="0" anchor="t"/>
           <a:lstStyle/>
           <a:p>
-            <a:pPr algn="l" indent="0" marL="0">
+            <a:pPr marL="0" indent="0" algn="l">
               <a:lnSpc>
                 <a:spcPts val="2200"/>
               </a:lnSpc>
@@ -4792,7 +4543,7 @@
           <a:bodyPr wrap="square" lIns="0" tIns="0" rIns="0" bIns="0" rtlCol="0" anchor="t"/>
           <a:lstStyle/>
           <a:p>
-            <a:pPr algn="l" indent="0" marL="0">
+            <a:pPr marL="0" indent="0" algn="l">
               <a:spcAft>
                 <a:spcPts val="600"/>
               </a:spcAft>
@@ -4834,7 +4585,7 @@
           <a:bodyPr wrap="square" lIns="0" tIns="0" rIns="0" bIns="0" rtlCol="0" anchor="t"/>
           <a:lstStyle/>
           <a:p>
-            <a:pPr algn="l" indent="0" marL="0">
+            <a:pPr marL="0" indent="0" algn="l">
               <a:lnSpc>
                 <a:spcPts val="1260"/>
               </a:lnSpc>
@@ -4851,12 +4602,6 @@
               </a:rPr>
               <a:t>Built-in </a:t>
             </a:r>
-            <a:pPr algn="l" indent="0" marL="0">
-              <a:lnSpc>
-                <a:spcPts val="1260"/>
-              </a:lnSpc>
-              <a:buNone/>
-            </a:pPr>
             <a:r>
               <a:rPr lang="en-US" sz="900" b="1" dirty="0">
                 <a:solidFill>
@@ -4868,12 +4613,6 @@
               </a:rPr>
               <a:t>write_todos</a:t>
             </a:r>
-            <a:pPr algn="l" indent="0" marL="0">
-              <a:lnSpc>
-                <a:spcPts val="1260"/>
-              </a:lnSpc>
-              <a:buNone/>
-            </a:pPr>
             <a:r>
               <a:rPr lang="en-US" sz="900" dirty="0">
                 <a:solidFill>
@@ -4912,7 +4651,7 @@
           <a:bodyPr wrap="square" rtlCol="0" anchor="ctr"/>
           <a:lstStyle/>
           <a:p>
-            <a:pPr indent="0" marL="0">
+            <a:pPr marL="0" indent="0">
               <a:buNone/>
             </a:pPr>
             <a:endParaRPr lang="en-US" dirty="0"/>
@@ -4941,6 +4680,13 @@
             <a:prstDash val="solid"/>
           </a:ln>
         </p:spPr>
+        <p:txBody>
+          <a:bodyPr/>
+          <a:lstStyle/>
+          <a:p>
+            <a:endParaRPr lang="en-US"/>
+          </a:p>
+        </p:txBody>
       </p:sp>
       <p:sp>
         <p:nvSpPr>
@@ -4963,7 +4709,7 @@
           <a:bodyPr wrap="square" lIns="0" tIns="0" rIns="0" bIns="0" rtlCol="0" anchor="t"/>
           <a:lstStyle/>
           <a:p>
-            <a:pPr algn="l" indent="0" marL="0">
+            <a:pPr marL="0" indent="0" algn="l">
               <a:lnSpc>
                 <a:spcPts val="2200"/>
               </a:lnSpc>
@@ -5008,7 +4754,7 @@
           <a:bodyPr wrap="square" lIns="0" tIns="0" rIns="0" bIns="0" rtlCol="0" anchor="t"/>
           <a:lstStyle/>
           <a:p>
-            <a:pPr algn="l" indent="0" marL="0">
+            <a:pPr marL="0" indent="0" algn="l">
               <a:spcAft>
                 <a:spcPts val="600"/>
               </a:spcAft>
@@ -5050,7 +4796,7 @@
           <a:bodyPr wrap="square" lIns="0" tIns="0" rIns="0" bIns="0" rtlCol="0" anchor="t"/>
           <a:lstStyle/>
           <a:p>
-            <a:pPr algn="l" indent="0" marL="0">
+            <a:pPr marL="0" indent="0" algn="l">
               <a:lnSpc>
                 <a:spcPts val="1260"/>
               </a:lnSpc>
@@ -5067,12 +4813,6 @@
               </a:rPr>
               <a:t>State-backed </a:t>
             </a:r>
-            <a:pPr algn="l" indent="0" marL="0">
-              <a:lnSpc>
-                <a:spcPts val="1260"/>
-              </a:lnSpc>
-              <a:buNone/>
-            </a:pPr>
             <a:r>
               <a:rPr lang="en-US" sz="900" b="1" dirty="0">
                 <a:solidFill>
@@ -5084,12 +4824,6 @@
               </a:rPr>
               <a:t>ls / read_file / write_file / edit_file</a:t>
             </a:r>
-            <a:pPr algn="l" indent="0" marL="0">
-              <a:lnSpc>
-                <a:spcPts val="1260"/>
-              </a:lnSpc>
-              <a:buNone/>
-            </a:pPr>
             <a:r>
               <a:rPr lang="en-US" sz="900" dirty="0">
                 <a:solidFill>
@@ -5128,7 +4862,7 @@
           <a:bodyPr wrap="square" rtlCol="0" anchor="ctr"/>
           <a:lstStyle/>
           <a:p>
-            <a:pPr indent="0" marL="0">
+            <a:pPr marL="0" indent="0">
               <a:buNone/>
             </a:pPr>
             <a:endParaRPr lang="en-US" dirty="0"/>
@@ -5157,6 +4891,13 @@
             <a:prstDash val="solid"/>
           </a:ln>
         </p:spPr>
+        <p:txBody>
+          <a:bodyPr/>
+          <a:lstStyle/>
+          <a:p>
+            <a:endParaRPr lang="en-US"/>
+          </a:p>
+        </p:txBody>
       </p:sp>
       <p:sp>
         <p:nvSpPr>
@@ -5179,7 +4920,7 @@
           <a:bodyPr wrap="square" lIns="0" tIns="0" rIns="0" bIns="0" rtlCol="0" anchor="t"/>
           <a:lstStyle/>
           <a:p>
-            <a:pPr algn="l" indent="0" marL="0">
+            <a:pPr marL="0" indent="0" algn="l">
               <a:lnSpc>
                 <a:spcPts val="2200"/>
               </a:lnSpc>
@@ -5224,7 +4965,7 @@
           <a:bodyPr wrap="square" lIns="0" tIns="0" rIns="0" bIns="0" rtlCol="0" anchor="t"/>
           <a:lstStyle/>
           <a:p>
-            <a:pPr algn="l" indent="0" marL="0">
+            <a:pPr marL="0" indent="0" algn="l">
               <a:spcAft>
                 <a:spcPts val="600"/>
               </a:spcAft>
@@ -5266,7 +5007,7 @@
           <a:bodyPr wrap="square" lIns="0" tIns="0" rIns="0" bIns="0" rtlCol="0" anchor="t"/>
           <a:lstStyle/>
           <a:p>
-            <a:pPr algn="l" indent="0" marL="0">
+            <a:pPr marL="0" indent="0" algn="l">
               <a:lnSpc>
                 <a:spcPts val="1260"/>
               </a:lnSpc>
@@ -5310,7 +5051,7 @@
           <a:bodyPr wrap="square" rtlCol="0" anchor="ctr"/>
           <a:lstStyle/>
           <a:p>
-            <a:pPr indent="0" marL="0">
+            <a:pPr marL="0" indent="0">
               <a:buNone/>
             </a:pPr>
             <a:endParaRPr lang="en-US" dirty="0"/>
@@ -5339,6 +5080,13 @@
             <a:prstDash val="solid"/>
           </a:ln>
         </p:spPr>
+        <p:txBody>
+          <a:bodyPr/>
+          <a:lstStyle/>
+          <a:p>
+            <a:endParaRPr lang="en-US"/>
+          </a:p>
+        </p:txBody>
       </p:sp>
       <p:sp>
         <p:nvSpPr>
@@ -5361,7 +5109,7 @@
           <a:bodyPr wrap="square" lIns="0" tIns="0" rIns="0" bIns="0" rtlCol="0" anchor="t"/>
           <a:lstStyle/>
           <a:p>
-            <a:pPr algn="l" indent="0" marL="0">
+            <a:pPr marL="0" indent="0" algn="l">
               <a:lnSpc>
                 <a:spcPts val="2200"/>
               </a:lnSpc>
@@ -5406,7 +5154,7 @@
           <a:bodyPr wrap="square" lIns="0" tIns="0" rIns="0" bIns="0" rtlCol="0" anchor="t"/>
           <a:lstStyle/>
           <a:p>
-            <a:pPr algn="l" indent="0" marL="0">
+            <a:pPr marL="0" indent="0" algn="l">
               <a:spcAft>
                 <a:spcPts val="600"/>
               </a:spcAft>
@@ -5448,7 +5196,7 @@
           <a:bodyPr wrap="square" lIns="0" tIns="0" rIns="0" bIns="0" rtlCol="0" anchor="t"/>
           <a:lstStyle/>
           <a:p>
-            <a:pPr algn="l" indent="0" marL="0">
+            <a:pPr marL="0" indent="0" algn="l">
               <a:lnSpc>
                 <a:spcPts val="1260"/>
               </a:lnSpc>
@@ -5492,7 +5240,7 @@
           <a:bodyPr wrap="square" rtlCol="0" anchor="ctr"/>
           <a:lstStyle/>
           <a:p>
-            <a:pPr indent="0" marL="0">
+            <a:pPr marL="0" indent="0">
               <a:buNone/>
             </a:pPr>
             <a:endParaRPr lang="en-US" dirty="0"/>
@@ -5515,6 +5263,7 @@
         <a:solidFill>
           <a:srgbClr val="F8FAFC"/>
         </a:solidFill>
+        <a:effectLst/>
       </p:bgPr>
     </p:bg>
     <p:spTree>
@@ -5552,7 +5301,7 @@
           <a:bodyPr wrap="square" lIns="0" tIns="0" rIns="0" bIns="0" rtlCol="0" anchor="t"/>
           <a:lstStyle/>
           <a:p>
-            <a:pPr algn="l" indent="0" marL="0">
+            <a:pPr marL="0" indent="0" algn="l">
               <a:buNone/>
             </a:pPr>
             <a:r>
@@ -5593,7 +5342,7 @@
           <a:bodyPr wrap="square" rtlCol="0" anchor="ctr"/>
           <a:lstStyle/>
           <a:p>
-            <a:pPr indent="0" marL="0">
+            <a:pPr marL="0" indent="0">
               <a:buNone/>
             </a:pPr>
             <a:endParaRPr lang="en-US" dirty="0"/>
@@ -5621,7 +5370,7 @@
           <a:bodyPr wrap="square" lIns="0" tIns="0" rIns="0" bIns="0" rtlCol="0" anchor="t"/>
           <a:lstStyle/>
           <a:p>
-            <a:pPr algn="l" indent="0" marL="0">
+            <a:pPr marL="0" indent="0" algn="l">
               <a:buNone/>
             </a:pPr>
             <a:r>
@@ -5660,7 +5409,7 @@
           <a:bodyPr wrap="square" lIns="0" tIns="0" rIns="0" bIns="0" rtlCol="0" anchor="t"/>
           <a:lstStyle/>
           <a:p>
-            <a:pPr algn="l" indent="0" marL="0">
+            <a:pPr marL="0" indent="0" algn="l">
               <a:lnSpc>
                 <a:spcPts val="3220"/>
               </a:lnSpc>
@@ -5680,15 +5429,6 @@
               </a:rPr>
               <a:t>Stop tuning the model. </a:t>
             </a:r>
-            <a:pPr algn="l" indent="0" marL="0">
-              <a:lnSpc>
-                <a:spcPts val="3220"/>
-              </a:lnSpc>
-              <a:spcAft>
-                <a:spcPts val="600"/>
-              </a:spcAft>
-              <a:buNone/>
-            </a:pPr>
             <a:r>
               <a:rPr lang="en-US" sz="2800" b="1" dirty="0">
                 <a:solidFill>
@@ -5725,7 +5465,7 @@
           <a:bodyPr wrap="square" lIns="0" tIns="0" rIns="0" bIns="0" rtlCol="0" anchor="t"/>
           <a:lstStyle/>
           <a:p>
-            <a:pPr algn="l" indent="0" marL="0">
+            <a:pPr marL="0" indent="0" algn="l">
               <a:lnSpc>
                 <a:spcPts val="1680"/>
               </a:lnSpc>
@@ -5765,8 +5505,8 @@
           </a:solidFill>
           <a:ln/>
           <a:effectLst>
-            <a:outerShdw sx="100000" sy="100000" kx="0" ky="0" algn="bl" rotWithShape="0" blurRad="38100" dist="13470" dir="2700000">
-              <a:srgbClr val="0f172a">
+            <a:outerShdw blurRad="38100" dist="13470" dir="2700000" algn="bl" rotWithShape="0">
+              <a:srgbClr val="0F172A">
                 <a:alpha val="6000"/>
               </a:srgbClr>
             </a:outerShdw>
@@ -5776,7 +5516,7 @@
           <a:bodyPr wrap="square" rtlCol="0" anchor="ctr"/>
           <a:lstStyle/>
           <a:p>
-            <a:pPr indent="0" marL="0">
+            <a:pPr marL="0" indent="0">
               <a:buNone/>
             </a:pPr>
             <a:endParaRPr lang="en-US" dirty="0"/>
@@ -5805,6 +5545,13 @@
             <a:prstDash val="solid"/>
           </a:ln>
         </p:spPr>
+        <p:txBody>
+          <a:bodyPr/>
+          <a:lstStyle/>
+          <a:p>
+            <a:endParaRPr lang="en-US"/>
+          </a:p>
+        </p:txBody>
       </p:sp>
       <p:sp>
         <p:nvSpPr>
@@ -5827,7 +5574,7 @@
           <a:bodyPr wrap="square" lIns="0" tIns="0" rIns="0" bIns="0" rtlCol="0" anchor="t"/>
           <a:lstStyle/>
           <a:p>
-            <a:pPr algn="l" indent="0" marL="0">
+            <a:pPr marL="0" indent="0" algn="l">
               <a:spcAft>
                 <a:spcPts val="300"/>
               </a:spcAft>
@@ -5869,7 +5616,7 @@
           <a:bodyPr wrap="square" lIns="0" tIns="0" rIns="0" bIns="0" rtlCol="0" anchor="t"/>
           <a:lstStyle/>
           <a:p>
-            <a:pPr algn="l" indent="0" marL="0">
+            <a:pPr marL="0" indent="0" algn="l">
               <a:lnSpc>
                 <a:spcPts val="1260"/>
               </a:lnSpc>
@@ -5909,8 +5656,8 @@
           </a:solidFill>
           <a:ln/>
           <a:effectLst>
-            <a:outerShdw sx="100000" sy="100000" kx="0" ky="0" algn="bl" rotWithShape="0" blurRad="38100" dist="13470" dir="2700000">
-              <a:srgbClr val="0f172a">
+            <a:outerShdw blurRad="38100" dist="13470" dir="2700000" algn="bl" rotWithShape="0">
+              <a:srgbClr val="0F172A">
                 <a:alpha val="6000"/>
               </a:srgbClr>
             </a:outerShdw>
@@ -5920,7 +5667,7 @@
           <a:bodyPr wrap="square" rtlCol="0" anchor="ctr"/>
           <a:lstStyle/>
           <a:p>
-            <a:pPr indent="0" marL="0">
+            <a:pPr marL="0" indent="0">
               <a:buNone/>
             </a:pPr>
             <a:endParaRPr lang="en-US" dirty="0"/>
@@ -5949,6 +5696,13 @@
             <a:prstDash val="solid"/>
           </a:ln>
         </p:spPr>
+        <p:txBody>
+          <a:bodyPr/>
+          <a:lstStyle/>
+          <a:p>
+            <a:endParaRPr lang="en-US"/>
+          </a:p>
+        </p:txBody>
       </p:sp>
       <p:sp>
         <p:nvSpPr>
@@ -5971,7 +5725,7 @@
           <a:bodyPr wrap="square" lIns="0" tIns="0" rIns="0" bIns="0" rtlCol="0" anchor="t"/>
           <a:lstStyle/>
           <a:p>
-            <a:pPr algn="l" indent="0" marL="0">
+            <a:pPr marL="0" indent="0" algn="l">
               <a:spcAft>
                 <a:spcPts val="300"/>
               </a:spcAft>
@@ -6013,7 +5767,7 @@
           <a:bodyPr wrap="square" lIns="0" tIns="0" rIns="0" bIns="0" rtlCol="0" anchor="t"/>
           <a:lstStyle/>
           <a:p>
-            <a:pPr algn="l" indent="0" marL="0">
+            <a:pPr marL="0" indent="0" algn="l">
               <a:lnSpc>
                 <a:spcPts val="1260"/>
               </a:lnSpc>
@@ -6053,8 +5807,8 @@
           </a:solidFill>
           <a:ln/>
           <a:effectLst>
-            <a:outerShdw sx="100000" sy="100000" kx="0" ky="0" algn="bl" rotWithShape="0" blurRad="38100" dist="13470" dir="2700000">
-              <a:srgbClr val="0f172a">
+            <a:outerShdw blurRad="38100" dist="13470" dir="2700000" algn="bl" rotWithShape="0">
+              <a:srgbClr val="0F172A">
                 <a:alpha val="6000"/>
               </a:srgbClr>
             </a:outerShdw>
@@ -6064,7 +5818,7 @@
           <a:bodyPr wrap="square" rtlCol="0" anchor="ctr"/>
           <a:lstStyle/>
           <a:p>
-            <a:pPr indent="0" marL="0">
+            <a:pPr marL="0" indent="0">
               <a:buNone/>
             </a:pPr>
             <a:endParaRPr lang="en-US" dirty="0"/>
@@ -6093,6 +5847,13 @@
             <a:prstDash val="solid"/>
           </a:ln>
         </p:spPr>
+        <p:txBody>
+          <a:bodyPr/>
+          <a:lstStyle/>
+          <a:p>
+            <a:endParaRPr lang="en-US"/>
+          </a:p>
+        </p:txBody>
       </p:sp>
       <p:sp>
         <p:nvSpPr>
@@ -6115,7 +5876,7 @@
           <a:bodyPr wrap="square" lIns="0" tIns="0" rIns="0" bIns="0" rtlCol="0" anchor="t"/>
           <a:lstStyle/>
           <a:p>
-            <a:pPr algn="l" indent="0" marL="0">
+            <a:pPr marL="0" indent="0" algn="l">
               <a:spcAft>
                 <a:spcPts val="300"/>
               </a:spcAft>
@@ -6157,7 +5918,7 @@
           <a:bodyPr wrap="square" lIns="0" tIns="0" rIns="0" bIns="0" rtlCol="0" anchor="t"/>
           <a:lstStyle/>
           <a:p>
-            <a:pPr algn="l" indent="0" marL="0">
+            <a:pPr marL="0" indent="0" algn="l">
               <a:lnSpc>
                 <a:spcPts val="1260"/>
               </a:lnSpc>
@@ -6186,8 +5947,8 @@
         </p:nvSpPr>
         <p:spPr>
           <a:xfrm>
-            <a:off x="3947666" y="1752600"/>
-            <a:ext cx="4688235" cy="2920901"/>
+            <a:off x="3924002" y="1767185"/>
+            <a:ext cx="4688235" cy="3291995"/>
           </a:xfrm>
           <a:prstGeom prst="roundRect">
             <a:avLst>
@@ -6203,7 +5964,7 @@
           <a:bodyPr wrap="square" rtlCol="0" anchor="ctr"/>
           <a:lstStyle/>
           <a:p>
-            <a:pPr indent="0" marL="0">
+            <a:pPr marL="0" indent="0">
               <a:buNone/>
             </a:pPr>
             <a:endParaRPr lang="en-US" dirty="0"/>
@@ -6218,7 +5979,7 @@
         </p:nvSpPr>
         <p:spPr>
           <a:xfrm>
-            <a:off x="4227016" y="2031950"/>
+            <a:off x="4114506" y="1629519"/>
             <a:ext cx="4212125" cy="133350"/>
           </a:xfrm>
           <a:prstGeom prst="rect">
@@ -6231,7 +5992,7 @@
           <a:bodyPr wrap="square" lIns="0" tIns="0" rIns="0" bIns="0" rtlCol="0" anchor="t"/>
           <a:lstStyle/>
           <a:p>
-            <a:pPr algn="l" indent="0" marL="0">
+            <a:pPr marL="0" indent="0" algn="l">
               <a:spcAft>
                 <a:spcPts val="1400"/>
               </a:spcAft>
@@ -6260,7 +6021,7 @@
         </p:nvSpPr>
         <p:spPr>
           <a:xfrm>
-            <a:off x="4227016" y="2343001"/>
+            <a:off x="4197096" y="1875615"/>
             <a:ext cx="4129534" cy="539651"/>
           </a:xfrm>
           <a:prstGeom prst="rect">
@@ -6275,7 +6036,7 @@
           <a:bodyPr wrap="square" rtlCol="0" anchor="ctr"/>
           <a:lstStyle/>
           <a:p>
-            <a:pPr indent="0" marL="0">
+            <a:pPr marL="0" indent="0">
               <a:buNone/>
             </a:pPr>
             <a:endParaRPr lang="en-US" dirty="0"/>
@@ -6290,7 +6051,7 @@
         </p:nvSpPr>
         <p:spPr>
           <a:xfrm>
-            <a:off x="4246066" y="2343001"/>
+            <a:off x="4216146" y="1875615"/>
             <a:ext cx="0" cy="539651"/>
           </a:xfrm>
           <a:prstGeom prst="line">
@@ -6304,6 +6065,13 @@
             <a:prstDash val="solid"/>
           </a:ln>
         </p:spPr>
+        <p:txBody>
+          <a:bodyPr/>
+          <a:lstStyle/>
+          <a:p>
+            <a:endParaRPr lang="en-US"/>
+          </a:p>
+        </p:txBody>
       </p:sp>
       <p:sp>
         <p:nvSpPr>
@@ -6313,7 +6081,7 @@
         </p:nvSpPr>
         <p:spPr>
           <a:xfrm>
-            <a:off x="4442817" y="2546152"/>
+            <a:off x="4412897" y="2078766"/>
             <a:ext cx="906729" cy="133350"/>
           </a:xfrm>
           <a:prstGeom prst="rect">
@@ -6326,7 +6094,7 @@
           <a:bodyPr wrap="square" lIns="0" tIns="0" rIns="0" bIns="0" rtlCol="0" anchor="t"/>
           <a:lstStyle/>
           <a:p>
-            <a:pPr algn="l" indent="0" marL="0">
+            <a:pPr marL="0" indent="0" algn="l">
               <a:buNone/>
             </a:pPr>
             <a:r>
@@ -6352,7 +6120,7 @@
         </p:nvSpPr>
         <p:spPr>
           <a:xfrm>
-            <a:off x="5331768" y="2469952"/>
+            <a:off x="5301848" y="2002566"/>
             <a:ext cx="2904024" cy="285750"/>
           </a:xfrm>
           <a:prstGeom prst="rect">
@@ -6365,7 +6133,7 @@
           <a:bodyPr wrap="square" lIns="0" tIns="0" rIns="0" bIns="0" rtlCol="0" anchor="t"/>
           <a:lstStyle/>
           <a:p>
-            <a:pPr algn="l" indent="0" marL="0">
+            <a:pPr marL="0" indent="0" algn="l">
               <a:buNone/>
             </a:pPr>
             <a:r>
@@ -6391,7 +6159,7 @@
         </p:nvSpPr>
         <p:spPr>
           <a:xfrm>
-            <a:off x="4227016" y="2984153"/>
+            <a:off x="4197096" y="2516767"/>
             <a:ext cx="4129534" cy="539651"/>
           </a:xfrm>
           <a:prstGeom prst="rect">
@@ -6406,7 +6174,7 @@
           <a:bodyPr wrap="square" rtlCol="0" anchor="ctr"/>
           <a:lstStyle/>
           <a:p>
-            <a:pPr indent="0" marL="0">
+            <a:pPr marL="0" indent="0">
               <a:buNone/>
             </a:pPr>
             <a:endParaRPr lang="en-US" dirty="0"/>
@@ -6421,7 +6189,7 @@
         </p:nvSpPr>
         <p:spPr>
           <a:xfrm>
-            <a:off x="4246066" y="2984153"/>
+            <a:off x="4216146" y="2516767"/>
             <a:ext cx="0" cy="539651"/>
           </a:xfrm>
           <a:prstGeom prst="line">
@@ -6435,6 +6203,13 @@
             <a:prstDash val="solid"/>
           </a:ln>
         </p:spPr>
+        <p:txBody>
+          <a:bodyPr/>
+          <a:lstStyle/>
+          <a:p>
+            <a:endParaRPr lang="en-US"/>
+          </a:p>
+        </p:txBody>
       </p:sp>
       <p:sp>
         <p:nvSpPr>
@@ -6444,7 +6219,7 @@
         </p:nvSpPr>
         <p:spPr>
           <a:xfrm>
-            <a:off x="4442817" y="3187303"/>
+            <a:off x="4412897" y="2719917"/>
             <a:ext cx="906729" cy="133350"/>
           </a:xfrm>
           <a:prstGeom prst="rect">
@@ -6457,7 +6232,7 @@
           <a:bodyPr wrap="square" lIns="0" tIns="0" rIns="0" bIns="0" rtlCol="0" anchor="t"/>
           <a:lstStyle/>
           <a:p>
-            <a:pPr algn="l" indent="0" marL="0">
+            <a:pPr marL="0" indent="0" algn="l">
               <a:buNone/>
             </a:pPr>
             <a:r>
@@ -6483,7 +6258,7 @@
         </p:nvSpPr>
         <p:spPr>
           <a:xfrm>
-            <a:off x="5331768" y="3111103"/>
+            <a:off x="5301848" y="2643717"/>
             <a:ext cx="2904024" cy="285750"/>
           </a:xfrm>
           <a:prstGeom prst="rect">
@@ -6496,7 +6271,7 @@
           <a:bodyPr wrap="square" lIns="0" tIns="0" rIns="0" bIns="0" rtlCol="0" anchor="t"/>
           <a:lstStyle/>
           <a:p>
-            <a:pPr algn="l" indent="0" marL="0">
+            <a:pPr marL="0" indent="0" algn="l">
               <a:buNone/>
             </a:pPr>
             <a:r>
@@ -6522,7 +6297,7 @@
         </p:nvSpPr>
         <p:spPr>
           <a:xfrm>
-            <a:off x="4227016" y="3625304"/>
+            <a:off x="4197096" y="3157918"/>
             <a:ext cx="4129534" cy="539651"/>
           </a:xfrm>
           <a:prstGeom prst="rect">
@@ -6537,7 +6312,7 @@
           <a:bodyPr wrap="square" rtlCol="0" anchor="ctr"/>
           <a:lstStyle/>
           <a:p>
-            <a:pPr indent="0" marL="0">
+            <a:pPr marL="0" indent="0">
               <a:buNone/>
             </a:pPr>
             <a:endParaRPr lang="en-US" dirty="0"/>
@@ -6552,7 +6327,7 @@
         </p:nvSpPr>
         <p:spPr>
           <a:xfrm>
-            <a:off x="4246066" y="3625304"/>
+            <a:off x="4216146" y="3157918"/>
             <a:ext cx="0" cy="539651"/>
           </a:xfrm>
           <a:prstGeom prst="line">
@@ -6566,6 +6341,13 @@
             <a:prstDash val="solid"/>
           </a:ln>
         </p:spPr>
+        <p:txBody>
+          <a:bodyPr/>
+          <a:lstStyle/>
+          <a:p>
+            <a:endParaRPr lang="en-US"/>
+          </a:p>
+        </p:txBody>
       </p:sp>
       <p:sp>
         <p:nvSpPr>
@@ -6575,7 +6357,7 @@
         </p:nvSpPr>
         <p:spPr>
           <a:xfrm>
-            <a:off x="4442817" y="3828455"/>
+            <a:off x="4412897" y="3361069"/>
             <a:ext cx="906729" cy="133350"/>
           </a:xfrm>
           <a:prstGeom prst="rect">
@@ -6588,7 +6370,7 @@
           <a:bodyPr wrap="square" lIns="0" tIns="0" rIns="0" bIns="0" rtlCol="0" anchor="t"/>
           <a:lstStyle/>
           <a:p>
-            <a:pPr algn="l" indent="0" marL="0">
+            <a:pPr marL="0" indent="0" algn="l">
               <a:buNone/>
             </a:pPr>
             <a:r>
@@ -6614,7 +6396,7 @@
         </p:nvSpPr>
         <p:spPr>
           <a:xfrm>
-            <a:off x="5331768" y="3752255"/>
+            <a:off x="5301848" y="3284869"/>
             <a:ext cx="2904024" cy="285750"/>
           </a:xfrm>
           <a:prstGeom prst="rect">
@@ -6627,7 +6409,7 @@
           <a:bodyPr wrap="square" lIns="0" tIns="0" rIns="0" bIns="0" rtlCol="0" anchor="t"/>
           <a:lstStyle/>
           <a:p>
-            <a:pPr algn="l" indent="0" marL="0">
+            <a:pPr marL="0" indent="0" algn="l">
               <a:buNone/>
             </a:pPr>
             <a:r>
@@ -6653,7 +6435,7 @@
         </p:nvSpPr>
         <p:spPr>
           <a:xfrm>
-            <a:off x="4227016" y="4266456"/>
+            <a:off x="4197096" y="3799070"/>
             <a:ext cx="4129534" cy="539651"/>
           </a:xfrm>
           <a:prstGeom prst="rect">
@@ -6668,7 +6450,7 @@
           <a:bodyPr wrap="square" rtlCol="0" anchor="ctr"/>
           <a:lstStyle/>
           <a:p>
-            <a:pPr indent="0" marL="0">
+            <a:pPr marL="0" indent="0">
               <a:buNone/>
             </a:pPr>
             <a:endParaRPr lang="en-US" dirty="0"/>
@@ -6683,7 +6465,7 @@
         </p:nvSpPr>
         <p:spPr>
           <a:xfrm>
-            <a:off x="4246066" y="4266456"/>
+            <a:off x="4216146" y="3799070"/>
             <a:ext cx="0" cy="539651"/>
           </a:xfrm>
           <a:prstGeom prst="line">
@@ -6697,6 +6479,13 @@
             <a:prstDash val="solid"/>
           </a:ln>
         </p:spPr>
+        <p:txBody>
+          <a:bodyPr/>
+          <a:lstStyle/>
+          <a:p>
+            <a:endParaRPr lang="en-US"/>
+          </a:p>
+        </p:txBody>
       </p:sp>
       <p:sp>
         <p:nvSpPr>
@@ -6706,7 +6495,7 @@
         </p:nvSpPr>
         <p:spPr>
           <a:xfrm>
-            <a:off x="4442817" y="4469606"/>
+            <a:off x="4412897" y="4002220"/>
             <a:ext cx="906729" cy="133350"/>
           </a:xfrm>
           <a:prstGeom prst="rect">
@@ -6719,7 +6508,7 @@
           <a:bodyPr wrap="square" lIns="0" tIns="0" rIns="0" bIns="0" rtlCol="0" anchor="t"/>
           <a:lstStyle/>
           <a:p>
-            <a:pPr algn="l" indent="0" marL="0">
+            <a:pPr marL="0" indent="0" algn="l">
               <a:buNone/>
             </a:pPr>
             <a:r>
@@ -6745,7 +6534,7 @@
         </p:nvSpPr>
         <p:spPr>
           <a:xfrm>
-            <a:off x="5331768" y="4393406"/>
+            <a:off x="5301848" y="3926020"/>
             <a:ext cx="2904024" cy="285750"/>
           </a:xfrm>
           <a:prstGeom prst="rect">
@@ -6758,7 +6547,7 @@
           <a:bodyPr wrap="square" lIns="0" tIns="0" rIns="0" bIns="0" rtlCol="0" anchor="t"/>
           <a:lstStyle/>
           <a:p>
-            <a:pPr algn="l" indent="0" marL="0">
+            <a:pPr marL="0" indent="0" algn="l">
               <a:buNone/>
             </a:pPr>
             <a:r>
@@ -6784,7 +6573,7 @@
         </p:nvSpPr>
         <p:spPr>
           <a:xfrm>
-            <a:off x="4227016" y="4907607"/>
+            <a:off x="4155801" y="4449473"/>
             <a:ext cx="4129534" cy="539651"/>
           </a:xfrm>
           <a:prstGeom prst="rect">
@@ -6799,7 +6588,7 @@
           <a:bodyPr wrap="square" rtlCol="0" anchor="ctr"/>
           <a:lstStyle/>
           <a:p>
-            <a:pPr indent="0" marL="0">
+            <a:pPr marL="0" indent="0">
               <a:buNone/>
             </a:pPr>
             <a:endParaRPr lang="en-US" dirty="0"/>
@@ -6814,7 +6603,7 @@
         </p:nvSpPr>
         <p:spPr>
           <a:xfrm>
-            <a:off x="4246066" y="4907607"/>
+            <a:off x="4216146" y="4440221"/>
             <a:ext cx="0" cy="539651"/>
           </a:xfrm>
           <a:prstGeom prst="line">
@@ -6828,6 +6617,13 @@
             <a:prstDash val="solid"/>
           </a:ln>
         </p:spPr>
+        <p:txBody>
+          <a:bodyPr/>
+          <a:lstStyle/>
+          <a:p>
+            <a:endParaRPr lang="en-US"/>
+          </a:p>
+        </p:txBody>
       </p:sp>
       <p:sp>
         <p:nvSpPr>
@@ -6837,7 +6633,7 @@
         </p:nvSpPr>
         <p:spPr>
           <a:xfrm>
-            <a:off x="4442817" y="5110758"/>
+            <a:off x="4412897" y="4643372"/>
             <a:ext cx="906729" cy="133350"/>
           </a:xfrm>
           <a:prstGeom prst="rect">
@@ -6850,7 +6646,7 @@
           <a:bodyPr wrap="square" lIns="0" tIns="0" rIns="0" bIns="0" rtlCol="0" anchor="t"/>
           <a:lstStyle/>
           <a:p>
-            <a:pPr algn="l" indent="0" marL="0">
+            <a:pPr marL="0" indent="0" algn="l">
               <a:buNone/>
             </a:pPr>
             <a:r>
@@ -6876,7 +6672,7 @@
         </p:nvSpPr>
         <p:spPr>
           <a:xfrm>
-            <a:off x="5331768" y="5034558"/>
+            <a:off x="5301848" y="4567172"/>
             <a:ext cx="2904024" cy="285750"/>
           </a:xfrm>
           <a:prstGeom prst="rect">
@@ -6889,7 +6685,7 @@
           <a:bodyPr wrap="square" lIns="0" tIns="0" rIns="0" bIns="0" rtlCol="0" anchor="t"/>
           <a:lstStyle/>
           <a:p>
-            <a:pPr algn="l" indent="0" marL="0">
+            <a:pPr marL="0" indent="0" algn="l">
               <a:buNone/>
             </a:pPr>
             <a:r>
@@ -6909,52 +6705,13 @@
       </p:sp>
       <p:sp>
         <p:nvSpPr>
-          <p:cNvPr id="41" name="Text 39"/>
-          <p:cNvSpPr/>
-          <p:nvPr/>
-        </p:nvSpPr>
-        <p:spPr>
-          <a:xfrm>
-            <a:off x="4144426" y="4362450"/>
-            <a:ext cx="4212125" cy="133350"/>
-          </a:xfrm>
-          <a:prstGeom prst="rect">
-            <a:avLst/>
-          </a:prstGeom>
-          <a:noFill/>
-          <a:ln/>
-        </p:spPr>
-        <p:txBody>
-          <a:bodyPr wrap="square" lIns="0" tIns="0" rIns="0" bIns="0" rtlCol="0" anchor="t"/>
-          <a:lstStyle/>
-          <a:p>
-            <a:pPr algn="r" indent="0" marL="0">
-              <a:buNone/>
-            </a:pPr>
-            <a:r>
-              <a:rPr lang="en-US" sz="900" i="1" dirty="0">
-                <a:solidFill>
-                  <a:srgbClr val="06B6D4"/>
-                </a:solidFill>
-                <a:latin typeface="Arial" pitchFamily="34" charset="0"/>
-                <a:ea typeface="Arial" pitchFamily="34" charset="-122"/>
-                <a:cs typeface="Arial" pitchFamily="34" charset="-120"/>
-              </a:rPr>
-              <a:t>// "Don't build agents. Build harnesses."</a:t>
-            </a:r>
-            <a:endParaRPr lang="en-US" sz="900" dirty="0"/>
-          </a:p>
-        </p:txBody>
-      </p:sp>
-      <p:sp>
-        <p:nvSpPr>
           <p:cNvPr id="42" name="Text 40"/>
           <p:cNvSpPr/>
           <p:nvPr/>
         </p:nvSpPr>
         <p:spPr>
           <a:xfrm>
-            <a:off x="0" y="5041999"/>
+            <a:off x="0" y="4967222"/>
             <a:ext cx="9144000" cy="101501"/>
           </a:xfrm>
           <a:prstGeom prst="rect">
@@ -6969,7 +6726,7 @@
           <a:bodyPr wrap="square" rtlCol="0" anchor="ctr"/>
           <a:lstStyle/>
           <a:p>
-            <a:pPr indent="0" marL="0">
+            <a:pPr marL="0" indent="0">
               <a:buNone/>
             </a:pPr>
             <a:endParaRPr lang="en-US" dirty="0"/>
@@ -6992,6 +6749,7 @@
         <a:solidFill>
           <a:srgbClr val="0B1426"/>
         </a:solidFill>
+        <a:effectLst/>
       </p:bgPr>
     </p:bg>
     <p:spTree>
@@ -7029,7 +6787,7 @@
           <a:bodyPr wrap="square" lIns="0" tIns="0" rIns="0" bIns="0" rtlCol="0" anchor="t"/>
           <a:lstStyle/>
           <a:p>
-            <a:pPr algn="l" indent="0" marL="0">
+            <a:pPr marL="0" indent="0" algn="l">
               <a:buNone/>
             </a:pPr>
             <a:r>
@@ -7070,7 +6828,7 @@
           <a:bodyPr wrap="square" rtlCol="0" anchor="ctr"/>
           <a:lstStyle/>
           <a:p>
-            <a:pPr indent="0" marL="0">
+            <a:pPr marL="0" indent="0">
               <a:buNone/>
             </a:pPr>
             <a:endParaRPr lang="en-US" dirty="0"/>
@@ -7098,7 +6856,7 @@
           <a:bodyPr wrap="square" lIns="0" tIns="0" rIns="0" bIns="0" rtlCol="0" anchor="t"/>
           <a:lstStyle/>
           <a:p>
-            <a:pPr algn="l" indent="0" marL="0">
+            <a:pPr marL="0" indent="0" algn="l">
               <a:buNone/>
             </a:pPr>
             <a:r>
@@ -7137,7 +6895,7 @@
           <a:bodyPr wrap="square" lIns="0" tIns="0" rIns="0" bIns="0" rtlCol="0" anchor="t"/>
           <a:lstStyle/>
           <a:p>
-            <a:pPr algn="l" indent="0" marL="0">
+            <a:pPr marL="0" indent="0" algn="l">
               <a:lnSpc>
                 <a:spcPts val="2990"/>
               </a:lnSpc>
@@ -7157,15 +6915,6 @@
               </a:rPr>
               <a:t>End-to-end: </a:t>
             </a:r>
-            <a:pPr algn="l" indent="0" marL="0">
-              <a:lnSpc>
-                <a:spcPts val="2990"/>
-              </a:lnSpc>
-              <a:spcAft>
-                <a:spcPts val="400"/>
-              </a:spcAft>
-              <a:buNone/>
-            </a:pPr>
             <a:r>
               <a:rPr lang="en-US" sz="2600" b="1" dirty="0">
                 <a:solidFill>
@@ -7177,15 +6926,6 @@
               </a:rPr>
               <a:t>Synaptic Command</a:t>
             </a:r>
-            <a:pPr algn="l" indent="0" marL="0">
-              <a:lnSpc>
-                <a:spcPts val="2990"/>
-              </a:lnSpc>
-              <a:spcAft>
-                <a:spcPts val="400"/>
-              </a:spcAft>
-              <a:buNone/>
-            </a:pPr>
             <a:r>
               <a:rPr lang="en-US" sz="2600" dirty="0">
                 <a:solidFill>
@@ -7222,7 +6962,7 @@
           <a:bodyPr wrap="square" lIns="0" tIns="0" rIns="0" bIns="0" rtlCol="0" anchor="t"/>
           <a:lstStyle/>
           <a:p>
-            <a:pPr algn="l" indent="0" marL="0">
+            <a:pPr marL="0" indent="0" algn="l">
               <a:buNone/>
             </a:pPr>
             <a:r>
@@ -7265,7 +7005,7 @@
           <a:bodyPr wrap="square" rtlCol="0" anchor="ctr"/>
           <a:lstStyle/>
           <a:p>
-            <a:pPr indent="0" marL="0">
+            <a:pPr marL="0" indent="0">
               <a:buNone/>
             </a:pPr>
             <a:endParaRPr lang="en-US" dirty="0"/>
@@ -7294,6 +7034,13 @@
             <a:prstDash val="solid"/>
           </a:ln>
         </p:spPr>
+        <p:txBody>
+          <a:bodyPr/>
+          <a:lstStyle/>
+          <a:p>
+            <a:endParaRPr lang="en-US"/>
+          </a:p>
+        </p:txBody>
       </p:sp>
       <p:sp>
         <p:nvSpPr>
@@ -7316,7 +7063,7 @@
           <a:bodyPr wrap="square" lIns="0" tIns="0" rIns="0" bIns="0" rtlCol="0" anchor="t"/>
           <a:lstStyle/>
           <a:p>
-            <a:pPr algn="l" indent="0" marL="0">
+            <a:pPr marL="0" indent="0" algn="l">
               <a:spcAft>
                 <a:spcPts val="200"/>
               </a:spcAft>
@@ -7358,7 +7105,7 @@
           <a:bodyPr wrap="square" lIns="0" tIns="0" rIns="0" bIns="0" rtlCol="0" anchor="t"/>
           <a:lstStyle/>
           <a:p>
-            <a:pPr algn="l" indent="0" marL="0">
+            <a:pPr marL="0" indent="0" algn="l">
               <a:buNone/>
             </a:pPr>
             <a:r>
@@ -7397,7 +7144,7 @@
           <a:bodyPr wrap="square" lIns="0" tIns="0" rIns="0" bIns="0" rtlCol="0" anchor="t"/>
           <a:lstStyle/>
           <a:p>
-            <a:pPr algn="l" indent="0" marL="0">
+            <a:pPr marL="0" indent="0" algn="l">
               <a:buNone/>
             </a:pPr>
             <a:r>
@@ -7436,7 +7183,7 @@
           <a:bodyPr wrap="square" lIns="0" tIns="0" rIns="0" bIns="0" rtlCol="0" anchor="t"/>
           <a:lstStyle/>
           <a:p>
-            <a:pPr algn="ctr" indent="0" marL="0">
+            <a:pPr marL="0" indent="0" algn="ctr">
               <a:lnSpc>
                 <a:spcPts val="1000"/>
               </a:lnSpc>
@@ -7488,7 +7235,7 @@
           <a:bodyPr wrap="square" rtlCol="0" anchor="ctr"/>
           <a:lstStyle/>
           <a:p>
-            <a:pPr indent="0" marL="0">
+            <a:pPr marL="0" indent="0">
               <a:buNone/>
             </a:pPr>
             <a:endParaRPr lang="en-US" dirty="0"/>
@@ -7517,6 +7264,13 @@
             <a:prstDash val="solid"/>
           </a:ln>
         </p:spPr>
+        <p:txBody>
+          <a:bodyPr/>
+          <a:lstStyle/>
+          <a:p>
+            <a:endParaRPr lang="en-US"/>
+          </a:p>
+        </p:txBody>
       </p:sp>
       <p:sp>
         <p:nvSpPr>
@@ -7539,7 +7293,7 @@
           <a:bodyPr wrap="square" lIns="0" tIns="0" rIns="0" bIns="0" rtlCol="0" anchor="t"/>
           <a:lstStyle/>
           <a:p>
-            <a:pPr algn="l" indent="0" marL="0">
+            <a:pPr marL="0" indent="0" algn="l">
               <a:spcAft>
                 <a:spcPts val="200"/>
               </a:spcAft>
@@ -7581,7 +7335,7 @@
           <a:bodyPr wrap="square" lIns="0" tIns="0" rIns="0" bIns="0" rtlCol="0" anchor="t"/>
           <a:lstStyle/>
           <a:p>
-            <a:pPr algn="l" indent="0" marL="0">
+            <a:pPr marL="0" indent="0" algn="l">
               <a:buNone/>
             </a:pPr>
             <a:r>
@@ -7620,7 +7374,7 @@
           <a:bodyPr wrap="square" lIns="0" tIns="0" rIns="0" bIns="0" rtlCol="0" anchor="t"/>
           <a:lstStyle/>
           <a:p>
-            <a:pPr algn="l" indent="0" marL="0">
+            <a:pPr marL="0" indent="0" algn="l">
               <a:buNone/>
             </a:pPr>
             <a:r>
@@ -7659,7 +7413,7 @@
           <a:bodyPr wrap="square" lIns="0" tIns="0" rIns="0" bIns="0" rtlCol="0" anchor="t"/>
           <a:lstStyle/>
           <a:p>
-            <a:pPr algn="ctr" indent="0" marL="0">
+            <a:pPr marL="0" indent="0" algn="ctr">
               <a:lnSpc>
                 <a:spcPts val="1000"/>
               </a:lnSpc>
@@ -7711,7 +7465,7 @@
           <a:bodyPr wrap="square" rtlCol="0" anchor="ctr"/>
           <a:lstStyle/>
           <a:p>
-            <a:pPr indent="0" marL="0">
+            <a:pPr marL="0" indent="0">
               <a:buNone/>
             </a:pPr>
             <a:endParaRPr lang="en-US" dirty="0"/>
@@ -7740,6 +7494,13 @@
             <a:prstDash val="solid"/>
           </a:ln>
         </p:spPr>
+        <p:txBody>
+          <a:bodyPr/>
+          <a:lstStyle/>
+          <a:p>
+            <a:endParaRPr lang="en-US"/>
+          </a:p>
+        </p:txBody>
       </p:sp>
       <p:sp>
         <p:nvSpPr>
@@ -7762,7 +7523,7 @@
           <a:bodyPr wrap="square" lIns="0" tIns="0" rIns="0" bIns="0" rtlCol="0" anchor="t"/>
           <a:lstStyle/>
           <a:p>
-            <a:pPr algn="l" indent="0" marL="0">
+            <a:pPr marL="0" indent="0" algn="l">
               <a:spcAft>
                 <a:spcPts val="200"/>
               </a:spcAft>
@@ -7804,7 +7565,7 @@
           <a:bodyPr wrap="square" lIns="0" tIns="0" rIns="0" bIns="0" rtlCol="0" anchor="t"/>
           <a:lstStyle/>
           <a:p>
-            <a:pPr algn="l" indent="0" marL="0">
+            <a:pPr marL="0" indent="0" algn="l">
               <a:buNone/>
             </a:pPr>
             <a:r>
@@ -7843,7 +7604,7 @@
           <a:bodyPr wrap="square" lIns="0" tIns="0" rIns="0" bIns="0" rtlCol="0" anchor="t"/>
           <a:lstStyle/>
           <a:p>
-            <a:pPr algn="l" indent="0" marL="0">
+            <a:pPr marL="0" indent="0" algn="l">
               <a:buNone/>
             </a:pPr>
             <a:r>
@@ -7882,7 +7643,7 @@
           <a:bodyPr wrap="square" lIns="0" tIns="0" rIns="0" bIns="0" rtlCol="0" anchor="t"/>
           <a:lstStyle/>
           <a:p>
-            <a:pPr algn="ctr" indent="0" marL="0">
+            <a:pPr marL="0" indent="0" algn="ctr">
               <a:lnSpc>
                 <a:spcPts val="1000"/>
               </a:lnSpc>
@@ -7917,7 +7678,7 @@
         </p:nvSpPr>
         <p:spPr>
           <a:xfrm>
-            <a:off x="507950" y="4406205"/>
+            <a:off x="507950" y="4191249"/>
             <a:ext cx="1536502" cy="241102"/>
           </a:xfrm>
           <a:prstGeom prst="roundRect">
@@ -7934,7 +7695,7 @@
           <a:bodyPr wrap="square" rtlCol="0" anchor="ctr"/>
           <a:lstStyle/>
           <a:p>
-            <a:pPr indent="0" marL="0">
+            <a:pPr marL="0" indent="0">
               <a:buNone/>
             </a:pPr>
             <a:endParaRPr lang="en-US" dirty="0"/>
@@ -7949,7 +7710,7 @@
         </p:nvSpPr>
         <p:spPr>
           <a:xfrm>
-            <a:off x="609451" y="4469606"/>
+            <a:off x="609451" y="4254650"/>
             <a:ext cx="1360170" cy="114300"/>
           </a:xfrm>
           <a:prstGeom prst="rect">
@@ -7962,7 +7723,7 @@
           <a:bodyPr wrap="square" lIns="0" tIns="0" rIns="0" bIns="0" rtlCol="0" anchor="t"/>
           <a:lstStyle/>
           <a:p>
-            <a:pPr algn="l" indent="0" marL="0">
+            <a:pPr marL="0" indent="0" algn="l">
               <a:buNone/>
             </a:pPr>
             <a:r>
@@ -7988,7 +7749,7 @@
         </p:nvSpPr>
         <p:spPr>
           <a:xfrm>
-            <a:off x="2095202" y="4406205"/>
+            <a:off x="2095202" y="4191249"/>
             <a:ext cx="1536502" cy="241102"/>
           </a:xfrm>
           <a:prstGeom prst="roundRect">
@@ -8005,7 +7766,7 @@
           <a:bodyPr wrap="square" rtlCol="0" anchor="ctr"/>
           <a:lstStyle/>
           <a:p>
-            <a:pPr indent="0" marL="0">
+            <a:pPr marL="0" indent="0">
               <a:buNone/>
             </a:pPr>
             <a:endParaRPr lang="en-US" dirty="0"/>
@@ -8020,7 +7781,7 @@
         </p:nvSpPr>
         <p:spPr>
           <a:xfrm>
-            <a:off x="2196703" y="4469606"/>
+            <a:off x="2196703" y="4254650"/>
             <a:ext cx="1360170" cy="114300"/>
           </a:xfrm>
           <a:prstGeom prst="rect">
@@ -8033,7 +7794,7 @@
           <a:bodyPr wrap="square" lIns="0" tIns="0" rIns="0" bIns="0" rtlCol="0" anchor="t"/>
           <a:lstStyle/>
           <a:p>
-            <a:pPr algn="l" indent="0" marL="0">
+            <a:pPr marL="0" indent="0" algn="l">
               <a:buNone/>
             </a:pPr>
             <a:r>
@@ -8059,7 +7820,7 @@
         </p:nvSpPr>
         <p:spPr>
           <a:xfrm>
-            <a:off x="3682454" y="4406205"/>
+            <a:off x="3682454" y="4191249"/>
             <a:ext cx="1536502" cy="241102"/>
           </a:xfrm>
           <a:prstGeom prst="roundRect">
@@ -8076,7 +7837,7 @@
           <a:bodyPr wrap="square" rtlCol="0" anchor="ctr"/>
           <a:lstStyle/>
           <a:p>
-            <a:pPr indent="0" marL="0">
+            <a:pPr marL="0" indent="0">
               <a:buNone/>
             </a:pPr>
             <a:endParaRPr lang="en-US" dirty="0"/>
@@ -8091,7 +7852,7 @@
         </p:nvSpPr>
         <p:spPr>
           <a:xfrm>
-            <a:off x="3783955" y="4469606"/>
+            <a:off x="3783955" y="4254650"/>
             <a:ext cx="1360170" cy="114300"/>
           </a:xfrm>
           <a:prstGeom prst="rect">
@@ -8104,7 +7865,7 @@
           <a:bodyPr wrap="square" lIns="0" tIns="0" rIns="0" bIns="0" rtlCol="0" anchor="t"/>
           <a:lstStyle/>
           <a:p>
-            <a:pPr algn="l" indent="0" marL="0">
+            <a:pPr marL="0" indent="0" algn="l">
               <a:buNone/>
             </a:pPr>
             <a:r>
@@ -8130,7 +7891,7 @@
         </p:nvSpPr>
         <p:spPr>
           <a:xfrm>
-            <a:off x="507950" y="4698057"/>
+            <a:off x="507950" y="4483101"/>
             <a:ext cx="1536502" cy="241102"/>
           </a:xfrm>
           <a:prstGeom prst="roundRect">
@@ -8147,7 +7908,7 @@
           <a:bodyPr wrap="square" rtlCol="0" anchor="ctr"/>
           <a:lstStyle/>
           <a:p>
-            <a:pPr indent="0" marL="0">
+            <a:pPr marL="0" indent="0">
               <a:buNone/>
             </a:pPr>
             <a:endParaRPr lang="en-US" dirty="0"/>
@@ -8162,7 +7923,7 @@
         </p:nvSpPr>
         <p:spPr>
           <a:xfrm>
-            <a:off x="609451" y="4761458"/>
+            <a:off x="609451" y="4546502"/>
             <a:ext cx="1360170" cy="114300"/>
           </a:xfrm>
           <a:prstGeom prst="rect">
@@ -8175,7 +7936,7 @@
           <a:bodyPr wrap="square" lIns="0" tIns="0" rIns="0" bIns="0" rtlCol="0" anchor="t"/>
           <a:lstStyle/>
           <a:p>
-            <a:pPr algn="l" indent="0" marL="0">
+            <a:pPr marL="0" indent="0" algn="l">
               <a:buNone/>
             </a:pPr>
             <a:r>
@@ -8201,7 +7962,7 @@
         </p:nvSpPr>
         <p:spPr>
           <a:xfrm>
-            <a:off x="2095202" y="4698057"/>
+            <a:off x="2095202" y="4483101"/>
             <a:ext cx="1536502" cy="241102"/>
           </a:xfrm>
           <a:prstGeom prst="roundRect">
@@ -8218,7 +7979,7 @@
           <a:bodyPr wrap="square" rtlCol="0" anchor="ctr"/>
           <a:lstStyle/>
           <a:p>
-            <a:pPr indent="0" marL="0">
+            <a:pPr marL="0" indent="0">
               <a:buNone/>
             </a:pPr>
             <a:endParaRPr lang="en-US" dirty="0"/>
@@ -8233,7 +7994,7 @@
         </p:nvSpPr>
         <p:spPr>
           <a:xfrm>
-            <a:off x="2196703" y="4761458"/>
+            <a:off x="2196703" y="4546502"/>
             <a:ext cx="1360170" cy="114300"/>
           </a:xfrm>
           <a:prstGeom prst="rect">
@@ -8246,7 +8007,7 @@
           <a:bodyPr wrap="square" lIns="0" tIns="0" rIns="0" bIns="0" rtlCol="0" anchor="t"/>
           <a:lstStyle/>
           <a:p>
-            <a:pPr algn="l" indent="0" marL="0">
+            <a:pPr marL="0" indent="0" algn="l">
               <a:buNone/>
             </a:pPr>
             <a:r>
@@ -8272,7 +8033,7 @@
         </p:nvSpPr>
         <p:spPr>
           <a:xfrm>
-            <a:off x="3682454" y="4698057"/>
+            <a:off x="3682454" y="4483101"/>
             <a:ext cx="1536502" cy="241102"/>
           </a:xfrm>
           <a:prstGeom prst="roundRect">
@@ -8289,7 +8050,7 @@
           <a:bodyPr wrap="square" rtlCol="0" anchor="ctr"/>
           <a:lstStyle/>
           <a:p>
-            <a:pPr indent="0" marL="0">
+            <a:pPr marL="0" indent="0">
               <a:buNone/>
             </a:pPr>
             <a:endParaRPr lang="en-US" dirty="0"/>
@@ -8304,7 +8065,7 @@
         </p:nvSpPr>
         <p:spPr>
           <a:xfrm>
-            <a:off x="3783955" y="4761458"/>
+            <a:off x="3783955" y="4546502"/>
             <a:ext cx="1360170" cy="114300"/>
           </a:xfrm>
           <a:prstGeom prst="rect">
@@ -8317,7 +8078,7 @@
           <a:bodyPr wrap="square" lIns="0" tIns="0" rIns="0" bIns="0" rtlCol="0" anchor="t"/>
           <a:lstStyle/>
           <a:p>
-            <a:pPr algn="l" indent="0" marL="0">
+            <a:pPr marL="0" indent="0" algn="l">
               <a:buNone/>
             </a:pPr>
             <a:r>
@@ -8343,7 +8104,7 @@
         </p:nvSpPr>
         <p:spPr>
           <a:xfrm>
-            <a:off x="507950" y="4989909"/>
+            <a:off x="507950" y="4774953"/>
             <a:ext cx="1536502" cy="241102"/>
           </a:xfrm>
           <a:prstGeom prst="roundRect">
@@ -8360,7 +8121,7 @@
           <a:bodyPr wrap="square" rtlCol="0" anchor="ctr"/>
           <a:lstStyle/>
           <a:p>
-            <a:pPr indent="0" marL="0">
+            <a:pPr marL="0" indent="0">
               <a:buNone/>
             </a:pPr>
             <a:endParaRPr lang="en-US" dirty="0"/>
@@ -8375,7 +8136,7 @@
         </p:nvSpPr>
         <p:spPr>
           <a:xfrm>
-            <a:off x="609451" y="5053310"/>
+            <a:off x="609451" y="4838354"/>
             <a:ext cx="1360170" cy="114300"/>
           </a:xfrm>
           <a:prstGeom prst="rect">
@@ -8388,7 +8149,7 @@
           <a:bodyPr wrap="square" lIns="0" tIns="0" rIns="0" bIns="0" rtlCol="0" anchor="t"/>
           <a:lstStyle/>
           <a:p>
-            <a:pPr algn="l" indent="0" marL="0">
+            <a:pPr marL="0" indent="0" algn="l">
               <a:buNone/>
             </a:pPr>
             <a:r>
@@ -8414,7 +8175,7 @@
         </p:nvSpPr>
         <p:spPr>
           <a:xfrm>
-            <a:off x="2095202" y="4989909"/>
+            <a:off x="2095202" y="4774953"/>
             <a:ext cx="1536502" cy="241102"/>
           </a:xfrm>
           <a:prstGeom prst="roundRect">
@@ -8431,7 +8192,7 @@
           <a:bodyPr wrap="square" rtlCol="0" anchor="ctr"/>
           <a:lstStyle/>
           <a:p>
-            <a:pPr indent="0" marL="0">
+            <a:pPr marL="0" indent="0">
               <a:buNone/>
             </a:pPr>
             <a:endParaRPr lang="en-US" dirty="0"/>
@@ -8446,7 +8207,7 @@
         </p:nvSpPr>
         <p:spPr>
           <a:xfrm>
-            <a:off x="2196703" y="5053310"/>
+            <a:off x="2196703" y="4838354"/>
             <a:ext cx="1360170" cy="114300"/>
           </a:xfrm>
           <a:prstGeom prst="rect">
@@ -8459,7 +8220,7 @@
           <a:bodyPr wrap="square" lIns="0" tIns="0" rIns="0" bIns="0" rtlCol="0" anchor="t"/>
           <a:lstStyle/>
           <a:p>
-            <a:pPr algn="l" indent="0" marL="0">
+            <a:pPr marL="0" indent="0" algn="l">
               <a:buNone/>
             </a:pPr>
             <a:r>
@@ -8498,7 +8259,7 @@
           <a:bodyPr wrap="square" lIns="0" tIns="0" rIns="0" bIns="0" rtlCol="0" anchor="t"/>
           <a:lstStyle/>
           <a:p>
-            <a:pPr algn="l" indent="0" marL="0">
+            <a:pPr marL="0" indent="0" algn="l">
               <a:spcAft>
                 <a:spcPts val="1200"/>
               </a:spcAft>
@@ -8541,6 +8302,13 @@
             <a:prstDash val="solid"/>
           </a:ln>
         </p:spPr>
+        <p:txBody>
+          <a:bodyPr/>
+          <a:lstStyle/>
+          <a:p>
+            <a:endParaRPr lang="en-US"/>
+          </a:p>
+        </p:txBody>
       </p:sp>
       <p:sp>
         <p:nvSpPr>
@@ -8563,7 +8331,7 @@
           <a:bodyPr wrap="square" lIns="0" tIns="0" rIns="0" bIns="0" rtlCol="0" anchor="t"/>
           <a:lstStyle/>
           <a:p>
-            <a:pPr algn="l" indent="0" marL="0">
+            <a:pPr marL="0" indent="0" algn="l">
               <a:lnSpc>
                 <a:spcPts val="2800"/>
               </a:lnSpc>
@@ -8605,7 +8373,7 @@
           <a:bodyPr wrap="square" lIns="0" tIns="0" rIns="0" bIns="0" rtlCol="0" anchor="t"/>
           <a:lstStyle/>
           <a:p>
-            <a:pPr algn="l" indent="0" marL="0">
+            <a:pPr marL="0" indent="0" algn="l">
               <a:spcAft>
                 <a:spcPts val="200"/>
               </a:spcAft>
@@ -8647,7 +8415,7 @@
           <a:bodyPr wrap="square" lIns="0" tIns="0" rIns="0" bIns="0" rtlCol="0" anchor="t"/>
           <a:lstStyle/>
           <a:p>
-            <a:pPr algn="l" indent="0" marL="0">
+            <a:pPr marL="0" indent="0" algn="l">
               <a:lnSpc>
                 <a:spcPts val="1040"/>
               </a:lnSpc>
@@ -8690,6 +8458,13 @@
             <a:prstDash val="solid"/>
           </a:ln>
         </p:spPr>
+        <p:txBody>
+          <a:bodyPr/>
+          <a:lstStyle/>
+          <a:p>
+            <a:endParaRPr lang="en-US"/>
+          </a:p>
+        </p:txBody>
       </p:sp>
       <p:sp>
         <p:nvSpPr>
@@ -8712,7 +8487,7 @@
           <a:bodyPr wrap="square" lIns="0" tIns="0" rIns="0" bIns="0" rtlCol="0" anchor="t"/>
           <a:lstStyle/>
           <a:p>
-            <a:pPr algn="l" indent="0" marL="0">
+            <a:pPr marL="0" indent="0" algn="l">
               <a:lnSpc>
                 <a:spcPts val="2800"/>
               </a:lnSpc>
@@ -8754,7 +8529,7 @@
           <a:bodyPr wrap="square" lIns="0" tIns="0" rIns="0" bIns="0" rtlCol="0" anchor="t"/>
           <a:lstStyle/>
           <a:p>
-            <a:pPr algn="l" indent="0" marL="0">
+            <a:pPr marL="0" indent="0" algn="l">
               <a:spcAft>
                 <a:spcPts val="200"/>
               </a:spcAft>
@@ -8796,7 +8571,7 @@
           <a:bodyPr wrap="square" lIns="0" tIns="0" rIns="0" bIns="0" rtlCol="0" anchor="t"/>
           <a:lstStyle/>
           <a:p>
-            <a:pPr algn="l" indent="0" marL="0">
+            <a:pPr marL="0" indent="0" algn="l">
               <a:lnSpc>
                 <a:spcPts val="1040"/>
               </a:lnSpc>
@@ -8839,6 +8614,13 @@
             <a:prstDash val="solid"/>
           </a:ln>
         </p:spPr>
+        <p:txBody>
+          <a:bodyPr/>
+          <a:lstStyle/>
+          <a:p>
+            <a:endParaRPr lang="en-US"/>
+          </a:p>
+        </p:txBody>
       </p:sp>
       <p:sp>
         <p:nvSpPr>
@@ -8861,7 +8643,7 @@
           <a:bodyPr wrap="square" lIns="0" tIns="0" rIns="0" bIns="0" rtlCol="0" anchor="t"/>
           <a:lstStyle/>
           <a:p>
-            <a:pPr algn="l" indent="0" marL="0">
+            <a:pPr marL="0" indent="0" algn="l">
               <a:lnSpc>
                 <a:spcPts val="2800"/>
               </a:lnSpc>
@@ -8903,7 +8685,7 @@
           <a:bodyPr wrap="square" lIns="0" tIns="0" rIns="0" bIns="0" rtlCol="0" anchor="t"/>
           <a:lstStyle/>
           <a:p>
-            <a:pPr algn="l" indent="0" marL="0">
+            <a:pPr marL="0" indent="0" algn="l">
               <a:spcAft>
                 <a:spcPts val="200"/>
               </a:spcAft>
@@ -8945,7 +8727,7 @@
           <a:bodyPr wrap="square" lIns="0" tIns="0" rIns="0" bIns="0" rtlCol="0" anchor="t"/>
           <a:lstStyle/>
           <a:p>
-            <a:pPr algn="l" indent="0" marL="0">
+            <a:pPr marL="0" indent="0" algn="l">
               <a:lnSpc>
                 <a:spcPts val="1040"/>
               </a:lnSpc>
@@ -8989,7 +8771,7 @@
           <a:bodyPr wrap="square" rtlCol="0" anchor="ctr"/>
           <a:lstStyle/>
           <a:p>
-            <a:pPr indent="0" marL="0">
+            <a:pPr marL="0" indent="0">
               <a:buNone/>
             </a:pPr>
             <a:endParaRPr lang="en-US" dirty="0"/>
@@ -9018,6 +8800,13 @@
             <a:prstDash val="solid"/>
           </a:ln>
         </p:spPr>
+        <p:txBody>
+          <a:bodyPr/>
+          <a:lstStyle/>
+          <a:p>
+            <a:endParaRPr lang="en-US"/>
+          </a:p>
+        </p:txBody>
       </p:sp>
       <p:sp>
         <p:nvSpPr>
@@ -9040,7 +8829,7 @@
           <a:bodyPr wrap="square" lIns="0" tIns="0" rIns="0" bIns="0" rtlCol="0" anchor="t"/>
           <a:lstStyle/>
           <a:p>
-            <a:pPr algn="l" indent="0" marL="0">
+            <a:pPr marL="0" indent="0" algn="l">
               <a:spcAft>
                 <a:spcPts val="400"/>
               </a:spcAft>
@@ -9082,7 +8871,7 @@
           <a:bodyPr wrap="square" lIns="0" tIns="0" rIns="0" bIns="0" rtlCol="0" anchor="t"/>
           <a:lstStyle/>
           <a:p>
-            <a:pPr algn="l" indent="0" marL="0">
+            <a:pPr marL="0" indent="0" algn="l">
               <a:lnSpc>
                 <a:spcPts val="1350"/>
               </a:lnSpc>
@@ -9111,7 +8900,7 @@
         </p:nvSpPr>
         <p:spPr>
           <a:xfrm>
-            <a:off x="0" y="5041999"/>
+            <a:off x="2369" y="5041999"/>
             <a:ext cx="9144000" cy="101501"/>
           </a:xfrm>
           <a:prstGeom prst="rect">
@@ -9126,7 +8915,7 @@
           <a:bodyPr wrap="square" rtlCol="0" anchor="ctr"/>
           <a:lstStyle/>
           <a:p>
-            <a:pPr indent="0" marL="0">
+            <a:pPr marL="0" indent="0">
               <a:buNone/>
             </a:pPr>
             <a:endParaRPr lang="en-US" dirty="0"/>
@@ -9149,6 +8938,7 @@
         <a:solidFill>
           <a:srgbClr val="0B1426"/>
         </a:solidFill>
+        <a:effectLst/>
       </p:bgPr>
     </p:bg>
     <p:spTree>
@@ -9188,58 +8978,12 @@
           <a:bodyPr wrap="square" rtlCol="0" anchor="ctr"/>
           <a:lstStyle/>
           <a:p>
-            <a:pPr indent="0" marL="0">
+            <a:pPr marL="0" indent="0">
               <a:buNone/>
             </a:pPr>
             <a:endParaRPr lang="en-US" dirty="0"/>
           </a:p>
         </p:txBody>
-      </p:sp>
-      <p:sp>
-        <p:nvSpPr>
-          <p:cNvPr id="3" name="Shape 1"/>
-          <p:cNvSpPr/>
-          <p:nvPr/>
-        </p:nvSpPr>
-        <p:spPr>
-          <a:xfrm>
-            <a:off x="571500" y="4000500"/>
-            <a:ext cx="0" cy="1143000"/>
-          </a:xfrm>
-          <a:prstGeom prst="line">
-            <a:avLst/>
-          </a:prstGeom>
-          <a:noFill/>
-          <a:ln w="1143000">
-            <a:solidFill>
-              <a:srgbClr val="FFFFFF"/>
-            </a:solidFill>
-            <a:prstDash val="solid"/>
-          </a:ln>
-        </p:spPr>
-      </p:sp>
-      <p:sp>
-        <p:nvSpPr>
-          <p:cNvPr id="4" name="Shape 2"/>
-          <p:cNvSpPr/>
-          <p:nvPr/>
-        </p:nvSpPr>
-        <p:spPr>
-          <a:xfrm>
-            <a:off x="0" y="4572000"/>
-            <a:ext cx="1143000" cy="0"/>
-          </a:xfrm>
-          <a:prstGeom prst="line">
-            <a:avLst/>
-          </a:prstGeom>
-          <a:noFill/>
-          <a:ln w="1143000">
-            <a:solidFill>
-              <a:srgbClr val="06B6D4"/>
-            </a:solidFill>
-            <a:prstDash val="solid"/>
-          </a:ln>
-        </p:spPr>
       </p:sp>
       <p:sp>
         <p:nvSpPr>
@@ -9262,7 +9006,7 @@
           <a:bodyPr wrap="square" lIns="0" tIns="0" rIns="0" bIns="0" rtlCol="0" anchor="t"/>
           <a:lstStyle/>
           <a:p>
-            <a:pPr algn="l" indent="0" marL="0">
+            <a:pPr marL="0" indent="0" algn="l">
               <a:spcAft>
                 <a:spcPts val="1400"/>
               </a:spcAft>
@@ -9304,7 +9048,7 @@
           <a:bodyPr wrap="square" lIns="0" tIns="0" rIns="0" bIns="0" rtlCol="0" anchor="t"/>
           <a:lstStyle/>
           <a:p>
-            <a:pPr algn="l" indent="0" marL="0">
+            <a:pPr marL="0" indent="0" algn="l">
               <a:lnSpc>
                 <a:spcPts val="4180"/>
               </a:lnSpc>
@@ -9321,12 +9065,6 @@
               </a:rPr>
               <a:t>What we </a:t>
             </a:r>
-            <a:pPr algn="l" indent="0" marL="0">
-              <a:lnSpc>
-                <a:spcPts val="4180"/>
-              </a:lnSpc>
-              <a:buNone/>
-            </a:pPr>
             <a:r>
               <a:rPr lang="en-US" sz="3800" b="1" dirty="0">
                 <a:solidFill>
@@ -9338,12 +9076,6 @@
               </a:rPr>
               <a:t>actually</a:t>
             </a:r>
-            <a:pPr algn="l" indent="0" marL="0">
-              <a:lnSpc>
-                <a:spcPts val="4180"/>
-              </a:lnSpc>
-              <a:buNone/>
-            </a:pPr>
             <a:r>
               <a:rPr lang="en-US" sz="3800" dirty="0">
                 <a:solidFill>
@@ -9382,7 +9114,7 @@
           <a:bodyPr wrap="square" rtlCol="0" anchor="ctr"/>
           <a:lstStyle/>
           <a:p>
-            <a:pPr indent="0" marL="0">
+            <a:pPr marL="0" indent="0">
               <a:buNone/>
             </a:pPr>
             <a:endParaRPr lang="en-US" dirty="0"/>
@@ -9410,7 +9142,7 @@
           <a:bodyPr wrap="square" lIns="0" tIns="0" rIns="0" bIns="0" rtlCol="0" anchor="t"/>
           <a:lstStyle/>
           <a:p>
-            <a:pPr algn="l" indent="0" marL="0">
+            <a:pPr marL="0" indent="0" algn="l">
               <a:lnSpc>
                 <a:spcPts val="1980"/>
               </a:lnSpc>
@@ -9452,7 +9184,7 @@
           <a:bodyPr wrap="square" lIns="0" tIns="0" rIns="0" bIns="0" rtlCol="0" anchor="t"/>
           <a:lstStyle/>
           <a:p>
-            <a:pPr algn="l" indent="0" marL="0">
+            <a:pPr marL="0" indent="0" algn="l">
               <a:spcAft>
                 <a:spcPts val="200"/>
               </a:spcAft>
@@ -9494,7 +9226,7 @@
           <a:bodyPr wrap="square" lIns="0" tIns="0" rIns="0" bIns="0" rtlCol="0" anchor="t"/>
           <a:lstStyle/>
           <a:p>
-            <a:pPr algn="l" indent="0" marL="0">
+            <a:pPr marL="0" indent="0" algn="l">
               <a:lnSpc>
                 <a:spcPts val="1540"/>
               </a:lnSpc>
@@ -9536,7 +9268,7 @@
           <a:bodyPr wrap="square" lIns="0" tIns="0" rIns="0" bIns="0" rtlCol="0" anchor="t"/>
           <a:lstStyle/>
           <a:p>
-            <a:pPr algn="l" indent="0" marL="0">
+            <a:pPr marL="0" indent="0" algn="l">
               <a:lnSpc>
                 <a:spcPts val="1980"/>
               </a:lnSpc>
@@ -9578,7 +9310,7 @@
           <a:bodyPr wrap="square" lIns="0" tIns="0" rIns="0" bIns="0" rtlCol="0" anchor="t"/>
           <a:lstStyle/>
           <a:p>
-            <a:pPr algn="l" indent="0" marL="0">
+            <a:pPr marL="0" indent="0" algn="l">
               <a:spcAft>
                 <a:spcPts val="200"/>
               </a:spcAft>
@@ -9620,7 +9352,7 @@
           <a:bodyPr wrap="square" lIns="0" tIns="0" rIns="0" bIns="0" rtlCol="0" anchor="t"/>
           <a:lstStyle/>
           <a:p>
-            <a:pPr algn="l" indent="0" marL="0">
+            <a:pPr marL="0" indent="0" algn="l">
               <a:lnSpc>
                 <a:spcPts val="1540"/>
               </a:lnSpc>
@@ -9662,7 +9394,7 @@
           <a:bodyPr wrap="square" lIns="0" tIns="0" rIns="0" bIns="0" rtlCol="0" anchor="t"/>
           <a:lstStyle/>
           <a:p>
-            <a:pPr algn="l" indent="0" marL="0">
+            <a:pPr marL="0" indent="0" algn="l">
               <a:lnSpc>
                 <a:spcPts val="1980"/>
               </a:lnSpc>
@@ -9704,7 +9436,7 @@
           <a:bodyPr wrap="square" lIns="0" tIns="0" rIns="0" bIns="0" rtlCol="0" anchor="t"/>
           <a:lstStyle/>
           <a:p>
-            <a:pPr algn="l" indent="0" marL="0">
+            <a:pPr marL="0" indent="0" algn="l">
               <a:spcAft>
                 <a:spcPts val="200"/>
               </a:spcAft>
@@ -9746,7 +9478,7 @@
           <a:bodyPr wrap="square" lIns="0" tIns="0" rIns="0" bIns="0" rtlCol="0" anchor="t"/>
           <a:lstStyle/>
           <a:p>
-            <a:pPr algn="l" indent="0" marL="0">
+            <a:pPr marL="0" indent="0" algn="l">
               <a:lnSpc>
                 <a:spcPts val="1540"/>
               </a:lnSpc>
@@ -9775,8 +9507,8 @@
         </p:nvSpPr>
         <p:spPr>
           <a:xfrm>
-            <a:off x="5080248" y="3086695"/>
-            <a:ext cx="3555802" cy="1548854"/>
+            <a:off x="5260630" y="3774430"/>
+            <a:ext cx="3501121" cy="1046709"/>
           </a:xfrm>
           <a:prstGeom prst="rect">
             <a:avLst/>
@@ -9790,7 +9522,7 @@
           <a:bodyPr wrap="square" rtlCol="0" anchor="ctr"/>
           <a:lstStyle/>
           <a:p>
-            <a:pPr indent="0" marL="0">
+            <a:pPr marL="0" indent="0">
               <a:buNone/>
             </a:pPr>
             <a:endParaRPr lang="en-US" dirty="0"/>
@@ -9799,49 +9531,26 @@
       </p:sp>
       <p:sp>
         <p:nvSpPr>
-          <p:cNvPr id="18" name="Shape 16"/>
-          <p:cNvSpPr/>
-          <p:nvPr/>
-        </p:nvSpPr>
-        <p:spPr>
-          <a:xfrm>
-            <a:off x="5080248" y="3105745"/>
-            <a:ext cx="3555802" cy="0"/>
-          </a:xfrm>
-          <a:prstGeom prst="line">
-            <a:avLst/>
-          </a:prstGeom>
-          <a:noFill/>
-          <a:ln w="38100">
-            <a:solidFill>
-              <a:srgbClr val="7C3AED"/>
-            </a:solidFill>
-            <a:prstDash val="solid"/>
-          </a:ln>
-        </p:spPr>
-      </p:sp>
-      <p:sp>
-        <p:nvSpPr>
           <p:cNvPr id="19" name="Text 17"/>
           <p:cNvSpPr/>
           <p:nvPr/>
         </p:nvSpPr>
         <p:spPr>
           <a:xfrm>
-            <a:off x="5334149" y="3378696"/>
-            <a:ext cx="3108960" cy="133350"/>
-          </a:xfrm>
-          <a:prstGeom prst="rect">
-            <a:avLst/>
-          </a:prstGeom>
-          <a:noFill/>
-          <a:ln/>
-        </p:spPr>
-        <p:txBody>
-          <a:bodyPr wrap="square" lIns="0" tIns="0" rIns="0" bIns="0" rtlCol="0" anchor="t"/>
-          <a:lstStyle/>
-          <a:p>
-            <a:pPr algn="l" indent="0" marL="0">
+            <a:off x="5341644" y="4774258"/>
+            <a:ext cx="3061151" cy="90117"/>
+          </a:xfrm>
+          <a:prstGeom prst="rect">
+            <a:avLst/>
+          </a:prstGeom>
+          <a:noFill/>
+          <a:ln/>
+        </p:spPr>
+        <p:txBody>
+          <a:bodyPr wrap="square" lIns="0" tIns="0" rIns="0" bIns="0" rtlCol="0" anchor="t"/>
+          <a:lstStyle/>
+          <a:p>
+            <a:pPr marL="0" indent="0" algn="l">
               <a:spcAft>
                 <a:spcPts val="800"/>
               </a:spcAft>
@@ -9870,20 +9579,20 @@
         </p:nvSpPr>
         <p:spPr>
           <a:xfrm>
-            <a:off x="5334149" y="3613547"/>
-            <a:ext cx="3108960" cy="507802"/>
-          </a:xfrm>
-          <a:prstGeom prst="rect">
-            <a:avLst/>
-          </a:prstGeom>
-          <a:noFill/>
-          <a:ln/>
-        </p:spPr>
-        <p:txBody>
-          <a:bodyPr wrap="square" lIns="0" tIns="0" rIns="0" bIns="0" rtlCol="0" anchor="t"/>
-          <a:lstStyle/>
-          <a:p>
-            <a:pPr algn="l" indent="0" marL="0">
+            <a:off x="5341644" y="3847430"/>
+            <a:ext cx="3061151" cy="343170"/>
+          </a:xfrm>
+          <a:prstGeom prst="rect">
+            <a:avLst/>
+          </a:prstGeom>
+          <a:noFill/>
+          <a:ln/>
+        </p:spPr>
+        <p:txBody>
+          <a:bodyPr wrap="square" lIns="0" tIns="0" rIns="0" bIns="0" rtlCol="0" anchor="t"/>
+          <a:lstStyle/>
+          <a:p>
+            <a:pPr marL="0" indent="0" algn="l">
               <a:lnSpc>
                 <a:spcPts val="2000"/>
               </a:lnSpc>
@@ -9912,20 +9621,20 @@
         </p:nvSpPr>
         <p:spPr>
           <a:xfrm>
-            <a:off x="5334149" y="4248299"/>
-            <a:ext cx="3108960" cy="133350"/>
-          </a:xfrm>
-          <a:prstGeom prst="rect">
-            <a:avLst/>
-          </a:prstGeom>
-          <a:noFill/>
-          <a:ln/>
-        </p:spPr>
-        <p:txBody>
-          <a:bodyPr wrap="square" lIns="0" tIns="0" rIns="0" bIns="0" rtlCol="0" anchor="t"/>
-          <a:lstStyle/>
-          <a:p>
-            <a:pPr algn="l" indent="0" marL="0">
+            <a:off x="5341644" y="4482182"/>
+            <a:ext cx="3061151" cy="90117"/>
+          </a:xfrm>
+          <a:prstGeom prst="rect">
+            <a:avLst/>
+          </a:prstGeom>
+          <a:noFill/>
+          <a:ln/>
+        </p:spPr>
+        <p:txBody>
+          <a:bodyPr wrap="square" lIns="0" tIns="0" rIns="0" bIns="0" rtlCol="0" anchor="t"/>
+          <a:lstStyle/>
+          <a:p>
+            <a:pPr marL="0" indent="0" algn="l">
               <a:spcBef>
                 <a:spcPts val="1000"/>
               </a:spcBef>
@@ -9969,7 +9678,7 @@
           <a:bodyPr wrap="square" rtlCol="0" anchor="ctr"/>
           <a:lstStyle/>
           <a:p>
-            <a:pPr indent="0" marL="0">
+            <a:pPr marL="0" indent="0">
               <a:buNone/>
             </a:pPr>
             <a:endParaRPr lang="en-US" dirty="0"/>
@@ -10277,4 +9986,319 @@
     </a:ext>
   </a:extLst>
 </a:theme>
+</file>
+
+<file path=ppt/theme/theme2.xml><?xml version="1.0" encoding="utf-8"?>
+<a:theme xmlns:a="http://schemas.openxmlformats.org/drawingml/2006/main" name="Office Theme">
+  <a:themeElements>
+    <a:clrScheme name="Office">
+      <a:dk1>
+        <a:sysClr val="windowText" lastClr="000000"/>
+      </a:dk1>
+      <a:lt1>
+        <a:sysClr val="window" lastClr="FFFFFF"/>
+      </a:lt1>
+      <a:dk2>
+        <a:srgbClr val="0E2841"/>
+      </a:dk2>
+      <a:lt2>
+        <a:srgbClr val="E8E8E8"/>
+      </a:lt2>
+      <a:accent1>
+        <a:srgbClr val="156082"/>
+      </a:accent1>
+      <a:accent2>
+        <a:srgbClr val="E97132"/>
+      </a:accent2>
+      <a:accent3>
+        <a:srgbClr val="196B24"/>
+      </a:accent3>
+      <a:accent4>
+        <a:srgbClr val="0F9ED5"/>
+      </a:accent4>
+      <a:accent5>
+        <a:srgbClr val="A02B93"/>
+      </a:accent5>
+      <a:accent6>
+        <a:srgbClr val="4EA72E"/>
+      </a:accent6>
+      <a:hlink>
+        <a:srgbClr val="467886"/>
+      </a:hlink>
+      <a:folHlink>
+        <a:srgbClr val="96607D"/>
+      </a:folHlink>
+    </a:clrScheme>
+    <a:fontScheme name="Office">
+      <a:majorFont>
+        <a:latin typeface="Aptos Display" panose="02110004020202020204"/>
+        <a:ea typeface=""/>
+        <a:cs typeface=""/>
+        <a:font script="Jpan" typeface="游ゴシック Light"/>
+        <a:font script="Hang" typeface="맑은 고딕"/>
+        <a:font script="Hans" typeface="等线 Light"/>
+        <a:font script="Hant" typeface="新細明體"/>
+        <a:font script="Arab" typeface="Times New Roman"/>
+        <a:font script="Hebr" typeface="Times New Roman"/>
+        <a:font script="Thai" typeface="Angsana New"/>
+        <a:font script="Ethi" typeface="Nyala"/>
+        <a:font script="Beng" typeface="Vrinda"/>
+        <a:font script="Gujr" typeface="Shruti"/>
+        <a:font script="Khmr" typeface="MoolBoran"/>
+        <a:font script="Knda" typeface="Tunga"/>
+        <a:font script="Guru" typeface="Raavi"/>
+        <a:font script="Cans" typeface="Euphemia"/>
+        <a:font script="Cher" typeface="Plantagenet Cherokee"/>
+        <a:font script="Yiii" typeface="Microsoft Yi Baiti"/>
+        <a:font script="Tibt" typeface="Microsoft Himalaya"/>
+        <a:font script="Thaa" typeface="MV Boli"/>
+        <a:font script="Deva" typeface="Mangal"/>
+        <a:font script="Telu" typeface="Gautami"/>
+        <a:font script="Taml" typeface="Latha"/>
+        <a:font script="Syrc" typeface="Estrangelo Edessa"/>
+        <a:font script="Orya" typeface="Kalinga"/>
+        <a:font script="Mlym" typeface="Kartika"/>
+        <a:font script="Laoo" typeface="DokChampa"/>
+        <a:font script="Sinh" typeface="Iskoola Pota"/>
+        <a:font script="Mong" typeface="Mongolian Baiti"/>
+        <a:font script="Viet" typeface="Times New Roman"/>
+        <a:font script="Uigh" typeface="Microsoft Uighur"/>
+        <a:font script="Geor" typeface="Sylfaen"/>
+        <a:font script="Armn" typeface="Arial"/>
+        <a:font script="Bugi" typeface="Leelawadee UI"/>
+        <a:font script="Bopo" typeface="Microsoft JhengHei"/>
+        <a:font script="Java" typeface="Javanese Text"/>
+        <a:font script="Lisu" typeface="Segoe UI"/>
+        <a:font script="Mymr" typeface="Myanmar Text"/>
+        <a:font script="Nkoo" typeface="Ebrima"/>
+        <a:font script="Olck" typeface="Nirmala UI"/>
+        <a:font script="Osma" typeface="Ebrima"/>
+        <a:font script="Phag" typeface="Phagspa"/>
+        <a:font script="Syrn" typeface="Estrangelo Edessa"/>
+        <a:font script="Syrj" typeface="Estrangelo Edessa"/>
+        <a:font script="Syre" typeface="Estrangelo Edessa"/>
+        <a:font script="Sora" typeface="Nirmala UI"/>
+        <a:font script="Tale" typeface="Microsoft Tai Le"/>
+        <a:font script="Talu" typeface="Microsoft New Tai Lue"/>
+        <a:font script="Tfng" typeface="Ebrima"/>
+      </a:majorFont>
+      <a:minorFont>
+        <a:latin typeface="Aptos" panose="02110004020202020204"/>
+        <a:ea typeface=""/>
+        <a:cs typeface=""/>
+        <a:font script="Jpan" typeface="游ゴシック"/>
+        <a:font script="Hang" typeface="맑은 고딕"/>
+        <a:font script="Hans" typeface="等线"/>
+        <a:font script="Hant" typeface="新細明體"/>
+        <a:font script="Arab" typeface="Arial"/>
+        <a:font script="Hebr" typeface="Arial"/>
+        <a:font script="Thai" typeface="Cordia New"/>
+        <a:font script="Ethi" typeface="Nyala"/>
+        <a:font script="Beng" typeface="Vrinda"/>
+        <a:font script="Gujr" typeface="Shruti"/>
+        <a:font script="Khmr" typeface="DaunPenh"/>
+        <a:font script="Knda" typeface="Tunga"/>
+        <a:font script="Guru" typeface="Raavi"/>
+        <a:font script="Cans" typeface="Euphemia"/>
+        <a:font script="Cher" typeface="Plantagenet Cherokee"/>
+        <a:font script="Yiii" typeface="Microsoft Yi Baiti"/>
+        <a:font script="Tibt" typeface="Microsoft Himalaya"/>
+        <a:font script="Thaa" typeface="MV Boli"/>
+        <a:font script="Deva" typeface="Mangal"/>
+        <a:font script="Telu" typeface="Gautami"/>
+        <a:font script="Taml" typeface="Latha"/>
+        <a:font script="Syrc" typeface="Estrangelo Edessa"/>
+        <a:font script="Orya" typeface="Kalinga"/>
+        <a:font script="Mlym" typeface="Kartika"/>
+        <a:font script="Laoo" typeface="DokChampa"/>
+        <a:font script="Sinh" typeface="Iskoola Pota"/>
+        <a:font script="Mong" typeface="Mongolian Baiti"/>
+        <a:font script="Viet" typeface="Arial"/>
+        <a:font script="Uigh" typeface="Microsoft Uighur"/>
+        <a:font script="Geor" typeface="Sylfaen"/>
+        <a:font script="Armn" typeface="Arial"/>
+        <a:font script="Bugi" typeface="Leelawadee UI"/>
+        <a:font script="Bopo" typeface="Microsoft JhengHei"/>
+        <a:font script="Java" typeface="Javanese Text"/>
+        <a:font script="Lisu" typeface="Segoe UI"/>
+        <a:font script="Mymr" typeface="Myanmar Text"/>
+        <a:font script="Nkoo" typeface="Ebrima"/>
+        <a:font script="Olck" typeface="Nirmala UI"/>
+        <a:font script="Osma" typeface="Ebrima"/>
+        <a:font script="Phag" typeface="Phagspa"/>
+        <a:font script="Syrn" typeface="Estrangelo Edessa"/>
+        <a:font script="Syrj" typeface="Estrangelo Edessa"/>
+        <a:font script="Syre" typeface="Estrangelo Edessa"/>
+        <a:font script="Sora" typeface="Nirmala UI"/>
+        <a:font script="Tale" typeface="Microsoft Tai Le"/>
+        <a:font script="Talu" typeface="Microsoft New Tai Lue"/>
+        <a:font script="Tfng" typeface="Ebrima"/>
+      </a:minorFont>
+    </a:fontScheme>
+    <a:fmtScheme name="Office">
+      <a:fillStyleLst>
+        <a:solidFill>
+          <a:schemeClr val="phClr"/>
+        </a:solidFill>
+        <a:gradFill rotWithShape="1">
+          <a:gsLst>
+            <a:gs pos="0">
+              <a:schemeClr val="phClr">
+                <a:lumMod val="110000"/>
+                <a:satMod val="105000"/>
+                <a:tint val="67000"/>
+              </a:schemeClr>
+            </a:gs>
+            <a:gs pos="50000">
+              <a:schemeClr val="phClr">
+                <a:lumMod val="105000"/>
+                <a:satMod val="103000"/>
+                <a:tint val="73000"/>
+              </a:schemeClr>
+            </a:gs>
+            <a:gs pos="100000">
+              <a:schemeClr val="phClr">
+                <a:lumMod val="105000"/>
+                <a:satMod val="109000"/>
+                <a:tint val="81000"/>
+              </a:schemeClr>
+            </a:gs>
+          </a:gsLst>
+          <a:lin ang="5400000" scaled="0"/>
+        </a:gradFill>
+        <a:gradFill rotWithShape="1">
+          <a:gsLst>
+            <a:gs pos="0">
+              <a:schemeClr val="phClr">
+                <a:satMod val="103000"/>
+                <a:lumMod val="102000"/>
+                <a:tint val="94000"/>
+              </a:schemeClr>
+            </a:gs>
+            <a:gs pos="50000">
+              <a:schemeClr val="phClr">
+                <a:satMod val="110000"/>
+                <a:lumMod val="100000"/>
+                <a:shade val="100000"/>
+              </a:schemeClr>
+            </a:gs>
+            <a:gs pos="100000">
+              <a:schemeClr val="phClr">
+                <a:lumMod val="99000"/>
+                <a:satMod val="120000"/>
+                <a:shade val="78000"/>
+              </a:schemeClr>
+            </a:gs>
+          </a:gsLst>
+          <a:lin ang="5400000" scaled="0"/>
+        </a:gradFill>
+      </a:fillStyleLst>
+      <a:lnStyleLst>
+        <a:ln w="12700" cap="flat" cmpd="sng" algn="ctr">
+          <a:solidFill>
+            <a:schemeClr val="phClr"/>
+          </a:solidFill>
+          <a:prstDash val="solid"/>
+          <a:miter lim="800000"/>
+        </a:ln>
+        <a:ln w="19050" cap="flat" cmpd="sng" algn="ctr">
+          <a:solidFill>
+            <a:schemeClr val="phClr"/>
+          </a:solidFill>
+          <a:prstDash val="solid"/>
+          <a:miter lim="800000"/>
+        </a:ln>
+        <a:ln w="25400" cap="flat" cmpd="sng" algn="ctr">
+          <a:solidFill>
+            <a:schemeClr val="phClr"/>
+          </a:solidFill>
+          <a:prstDash val="solid"/>
+          <a:miter lim="800000"/>
+        </a:ln>
+      </a:lnStyleLst>
+      <a:effectStyleLst>
+        <a:effectStyle>
+          <a:effectLst/>
+        </a:effectStyle>
+        <a:effectStyle>
+          <a:effectLst/>
+        </a:effectStyle>
+        <a:effectStyle>
+          <a:effectLst>
+            <a:outerShdw blurRad="57150" dist="19050" dir="5400000" algn="ctr" rotWithShape="0">
+              <a:srgbClr val="000000">
+                <a:alpha val="63000"/>
+              </a:srgbClr>
+            </a:outerShdw>
+          </a:effectLst>
+        </a:effectStyle>
+      </a:effectStyleLst>
+      <a:bgFillStyleLst>
+        <a:solidFill>
+          <a:schemeClr val="phClr"/>
+        </a:solidFill>
+        <a:solidFill>
+          <a:schemeClr val="phClr">
+            <a:tint val="95000"/>
+            <a:satMod val="170000"/>
+          </a:schemeClr>
+        </a:solidFill>
+        <a:gradFill rotWithShape="1">
+          <a:gsLst>
+            <a:gs pos="0">
+              <a:schemeClr val="phClr">
+                <a:tint val="93000"/>
+                <a:satMod val="150000"/>
+                <a:shade val="98000"/>
+                <a:lumMod val="102000"/>
+              </a:schemeClr>
+            </a:gs>
+            <a:gs pos="50000">
+              <a:schemeClr val="phClr">
+                <a:tint val="98000"/>
+                <a:satMod val="130000"/>
+                <a:shade val="90000"/>
+                <a:lumMod val="103000"/>
+              </a:schemeClr>
+            </a:gs>
+            <a:gs pos="100000">
+              <a:schemeClr val="phClr">
+                <a:shade val="63000"/>
+                <a:satMod val="120000"/>
+              </a:schemeClr>
+            </a:gs>
+          </a:gsLst>
+          <a:lin ang="5400000" scaled="0"/>
+        </a:gradFill>
+      </a:bgFillStyleLst>
+    </a:fmtScheme>
+  </a:themeElements>
+  <a:objectDefaults>
+    <a:lnDef>
+      <a:spPr/>
+      <a:bodyPr/>
+      <a:lstStyle/>
+      <a:style>
+        <a:lnRef idx="2">
+          <a:schemeClr val="accent1"/>
+        </a:lnRef>
+        <a:fillRef idx="0">
+          <a:schemeClr val="accent1"/>
+        </a:fillRef>
+        <a:effectRef idx="1">
+          <a:schemeClr val="accent1"/>
+        </a:effectRef>
+        <a:fontRef idx="minor">
+          <a:schemeClr val="tx1"/>
+        </a:fontRef>
+      </a:style>
+    </a:lnDef>
+  </a:objectDefaults>
+  <a:extraClrSchemeLst/>
+  <a:extLst>
+    <a:ext uri="{05A4C25C-085E-4340-85A3-A5531E510DB2}">
+      <thm15:themeFamily xmlns:thm15="http://schemas.microsoft.com/office/thememl/2012/main" name="Office Theme" id="{2E142A2C-CD16-42D6-873A-C26D2A0506FA}" vid="{1BDDFF52-6CD6-40A5-AB3C-68EB2F1E4D0A}"/>
+    </a:ext>
+  </a:extLst>
+</a:theme>
 </file>
</xml_diff>